<commit_message>
read some pallux , it is difficult to read because \ there are some math equation, and I cannot catch the relationship between agent and scheduler . I just konow scheduler could calculate fitness ,  maybe we could use DRL, but I have some probnlems , first is input and output , reward , implment is quite complex , many things needs to figure out , this is pytorch may be easier than DL2, and newer.\ I need give prof some feed back , implemnt , I need reproduce some results tomorrow and list the logic of polloux
</commit_message>
<xml_diff>
--- a/week report/8.18 report.pptx
+++ b/week report/8.18 report.pptx
@@ -5,7 +5,7 @@
     <p:sldMasterId id="2147483648" r:id="rId1"/>
   </p:sldMasterIdLst>
   <p:notesMasterIdLst>
-    <p:notesMasterId r:id="rId10"/>
+    <p:notesMasterId r:id="rId11"/>
   </p:notesMasterIdLst>
   <p:sldIdLst>
     <p:sldId id="263" r:id="rId2"/>
@@ -14,8 +14,9 @@
     <p:sldId id="276" r:id="rId5"/>
     <p:sldId id="277" r:id="rId6"/>
     <p:sldId id="278" r:id="rId7"/>
-    <p:sldId id="264" r:id="rId8"/>
-    <p:sldId id="273" r:id="rId9"/>
+    <p:sldId id="279" r:id="rId8"/>
+    <p:sldId id="264" r:id="rId9"/>
+    <p:sldId id="273" r:id="rId10"/>
   </p:sldIdLst>
   <p:sldSz cx="12192000" cy="6858000"/>
   <p:notesSz cx="6858000" cy="9144000"/>
@@ -204,7 +205,7 @@
           <a:p>
             <a:fld id="{F4BC8E43-2426-4AB4-B1DA-94A32D613D40}" type="datetimeFigureOut">
               <a:rPr lang="zh-CN" altLang="en-US" smtClean="0"/>
-              <a:t>2021/8/11</a:t>
+              <a:t>2021/8/13</a:t>
             </a:fld>
             <a:endParaRPr lang="zh-CN" altLang="en-US"/>
           </a:p>
@@ -1002,6 +1003,90 @@
     </p:spTree>
     <p:extLst>
       <p:ext uri="{BB962C8B-B14F-4D97-AF65-F5344CB8AC3E}">
+        <p14:creationId xmlns:p14="http://schemas.microsoft.com/office/powerpoint/2010/main" val="3987705652"/>
+      </p:ext>
+    </p:extLst>
+  </p:cSld>
+  <p:clrMapOvr>
+    <a:masterClrMapping/>
+  </p:clrMapOvr>
+</p:notes>
+</file>
+
+<file path=ppt/notesSlides/notesSlide7.xml><?xml version="1.0" encoding="utf-8"?>
+<p:notes xmlns:a="http://schemas.openxmlformats.org/drawingml/2006/main" xmlns:r="http://schemas.openxmlformats.org/officeDocument/2006/relationships" xmlns:p="http://schemas.openxmlformats.org/presentationml/2006/main">
+  <p:cSld>
+    <p:spTree>
+      <p:nvGrpSpPr>
+        <p:cNvPr id="1" name=""/>
+        <p:cNvGrpSpPr/>
+        <p:nvPr/>
+      </p:nvGrpSpPr>
+      <p:grpSpPr>
+        <a:xfrm>
+          <a:off x="0" y="0"/>
+          <a:ext cx="0" cy="0"/>
+          <a:chOff x="0" y="0"/>
+          <a:chExt cx="0" cy="0"/>
+        </a:xfrm>
+      </p:grpSpPr>
+      <p:sp>
+        <p:nvSpPr>
+          <p:cNvPr id="2" name="幻灯片图像占位符 1"/>
+          <p:cNvSpPr>
+            <a:spLocks noGrp="1" noRot="1" noChangeAspect="1"/>
+          </p:cNvSpPr>
+          <p:nvPr>
+            <p:ph type="sldImg"/>
+          </p:nvPr>
+        </p:nvSpPr>
+        <p:spPr/>
+      </p:sp>
+      <p:sp>
+        <p:nvSpPr>
+          <p:cNvPr id="3" name="备注占位符 2"/>
+          <p:cNvSpPr>
+            <a:spLocks noGrp="1"/>
+          </p:cNvSpPr>
+          <p:nvPr>
+            <p:ph type="body" idx="1"/>
+          </p:nvPr>
+        </p:nvSpPr>
+        <p:spPr/>
+        <p:txBody>
+          <a:bodyPr/>
+          <a:lstStyle/>
+          <a:p>
+            <a:endParaRPr lang="zh-CN" altLang="en-US" dirty="0"/>
+          </a:p>
+        </p:txBody>
+      </p:sp>
+      <p:sp>
+        <p:nvSpPr>
+          <p:cNvPr id="4" name="灯片编号占位符 3"/>
+          <p:cNvSpPr>
+            <a:spLocks noGrp="1"/>
+          </p:cNvSpPr>
+          <p:nvPr>
+            <p:ph type="sldNum" sz="quarter" idx="10"/>
+          </p:nvPr>
+        </p:nvSpPr>
+        <p:spPr/>
+        <p:txBody>
+          <a:bodyPr/>
+          <a:lstStyle/>
+          <a:p>
+            <a:fld id="{5CF06ACB-586E-4135-A9BA-C2B440FB252A}" type="slidenum">
+              <a:rPr lang="zh-CN" altLang="en-US" smtClean="0"/>
+              <a:t>8</a:t>
+            </a:fld>
+            <a:endParaRPr lang="zh-CN" altLang="en-US"/>
+          </a:p>
+        </p:txBody>
+      </p:sp>
+    </p:spTree>
+    <p:extLst>
+      <p:ext uri="{BB962C8B-B14F-4D97-AF65-F5344CB8AC3E}">
         <p14:creationId xmlns:p14="http://schemas.microsoft.com/office/powerpoint/2010/main" val="246271451"/>
       </p:ext>
     </p:extLst>
@@ -1143,7 +1228,7 @@
           <a:p>
             <a:fld id="{DCC080BC-FD8F-4BC7-912D-250C973482EE}" type="datetimeFigureOut">
               <a:rPr lang="zh-CN" altLang="en-US" smtClean="0"/>
-              <a:t>2021/8/11</a:t>
+              <a:t>2021/8/13</a:t>
             </a:fld>
             <a:endParaRPr lang="zh-CN" altLang="en-US"/>
           </a:p>
@@ -1313,7 +1398,7 @@
           <a:p>
             <a:fld id="{DCC080BC-FD8F-4BC7-912D-250C973482EE}" type="datetimeFigureOut">
               <a:rPr lang="zh-CN" altLang="en-US" smtClean="0"/>
-              <a:t>2021/8/11</a:t>
+              <a:t>2021/8/13</a:t>
             </a:fld>
             <a:endParaRPr lang="zh-CN" altLang="en-US"/>
           </a:p>
@@ -1493,7 +1578,7 @@
           <a:p>
             <a:fld id="{DCC080BC-FD8F-4BC7-912D-250C973482EE}" type="datetimeFigureOut">
               <a:rPr lang="zh-CN" altLang="en-US" smtClean="0"/>
-              <a:t>2021/8/11</a:t>
+              <a:t>2021/8/13</a:t>
             </a:fld>
             <a:endParaRPr lang="zh-CN" altLang="en-US"/>
           </a:p>
@@ -1663,7 +1748,7 @@
           <a:p>
             <a:fld id="{DCC080BC-FD8F-4BC7-912D-250C973482EE}" type="datetimeFigureOut">
               <a:rPr lang="zh-CN" altLang="en-US" smtClean="0"/>
-              <a:t>2021/8/11</a:t>
+              <a:t>2021/8/13</a:t>
             </a:fld>
             <a:endParaRPr lang="zh-CN" altLang="en-US"/>
           </a:p>
@@ -1909,7 +1994,7 @@
           <a:p>
             <a:fld id="{DCC080BC-FD8F-4BC7-912D-250C973482EE}" type="datetimeFigureOut">
               <a:rPr lang="zh-CN" altLang="en-US" smtClean="0"/>
-              <a:t>2021/8/11</a:t>
+              <a:t>2021/8/13</a:t>
             </a:fld>
             <a:endParaRPr lang="zh-CN" altLang="en-US"/>
           </a:p>
@@ -2141,7 +2226,7 @@
           <a:p>
             <a:fld id="{DCC080BC-FD8F-4BC7-912D-250C973482EE}" type="datetimeFigureOut">
               <a:rPr lang="zh-CN" altLang="en-US" smtClean="0"/>
-              <a:t>2021/8/11</a:t>
+              <a:t>2021/8/13</a:t>
             </a:fld>
             <a:endParaRPr lang="zh-CN" altLang="en-US"/>
           </a:p>
@@ -2508,7 +2593,7 @@
           <a:p>
             <a:fld id="{DCC080BC-FD8F-4BC7-912D-250C973482EE}" type="datetimeFigureOut">
               <a:rPr lang="zh-CN" altLang="en-US" smtClean="0"/>
-              <a:t>2021/8/11</a:t>
+              <a:t>2021/8/13</a:t>
             </a:fld>
             <a:endParaRPr lang="zh-CN" altLang="en-US"/>
           </a:p>
@@ -2626,7 +2711,7 @@
           <a:p>
             <a:fld id="{DCC080BC-FD8F-4BC7-912D-250C973482EE}" type="datetimeFigureOut">
               <a:rPr lang="zh-CN" altLang="en-US" smtClean="0"/>
-              <a:t>2021/8/11</a:t>
+              <a:t>2021/8/13</a:t>
             </a:fld>
             <a:endParaRPr lang="zh-CN" altLang="en-US"/>
           </a:p>
@@ -2721,7 +2806,7 @@
           <a:p>
             <a:fld id="{DCC080BC-FD8F-4BC7-912D-250C973482EE}" type="datetimeFigureOut">
               <a:rPr lang="zh-CN" altLang="en-US" smtClean="0"/>
-              <a:t>2021/8/11</a:t>
+              <a:t>2021/8/13</a:t>
             </a:fld>
             <a:endParaRPr lang="zh-CN" altLang="en-US"/>
           </a:p>
@@ -2998,7 +3083,7 @@
           <a:p>
             <a:fld id="{DCC080BC-FD8F-4BC7-912D-250C973482EE}" type="datetimeFigureOut">
               <a:rPr lang="zh-CN" altLang="en-US" smtClean="0"/>
-              <a:t>2021/8/11</a:t>
+              <a:t>2021/8/13</a:t>
             </a:fld>
             <a:endParaRPr lang="zh-CN" altLang="en-US"/>
           </a:p>
@@ -3251,7 +3336,7 @@
           <a:p>
             <a:fld id="{DCC080BC-FD8F-4BC7-912D-250C973482EE}" type="datetimeFigureOut">
               <a:rPr lang="zh-CN" altLang="en-US" smtClean="0"/>
-              <a:t>2021/8/11</a:t>
+              <a:t>2021/8/13</a:t>
             </a:fld>
             <a:endParaRPr lang="zh-CN" altLang="en-US"/>
           </a:p>
@@ -3464,7 +3549,7 @@
           <a:p>
             <a:fld id="{DCC080BC-FD8F-4BC7-912D-250C973482EE}" type="datetimeFigureOut">
               <a:rPr lang="zh-CN" altLang="en-US" smtClean="0"/>
-              <a:t>2021/8/11</a:t>
+              <a:t>2021/8/13</a:t>
             </a:fld>
             <a:endParaRPr lang="zh-CN" altLang="en-US"/>
           </a:p>
@@ -16570,7 +16655,7 @@
           <a:p>
             <a:fld id="{7E66CBCB-337D-49B6-B73D-DC76D0E029C4}" type="datetime1">
               <a:rPr lang="zh-CN" altLang="en-US" smtClean="0"/>
-              <a:t>2021/8/11</a:t>
+              <a:t>2021/8/13</a:t>
             </a:fld>
             <a:endParaRPr lang="zh-CN" altLang="en-US" dirty="0"/>
           </a:p>
@@ -17239,19 +17324,7 @@
                           <a:ea typeface="+mn-ea"/>
                           <a:cs typeface="+mn-cs"/>
                         </a:rPr>
-                        <a:t>同时调整</a:t>
-                      </a:r>
-                      <a:r>
-                        <a:rPr lang="zh-CN" altLang="en-US" sz="1800" b="0" i="0" kern="1200" dirty="0" smtClean="0">
-                          <a:solidFill>
-                            <a:schemeClr val="dk1"/>
-                          </a:solidFill>
-                          <a:effectLst/>
-                          <a:latin typeface="+mn-lt"/>
-                          <a:ea typeface="+mn-ea"/>
-                          <a:cs typeface="+mn-cs"/>
-                        </a:rPr>
-                        <a:t>资源和两个超参数</a:t>
+                        <a:t>同时调整资源和两个超参数</a:t>
                       </a:r>
                       <a:endParaRPr lang="zh-CN" altLang="en-US" dirty="0"/>
                     </a:p>
@@ -18305,11 +18378,7 @@
                       </a:r>
                       <a:r>
                         <a:rPr lang="zh-CN" altLang="en-US" dirty="0" smtClean="0"/>
-                        <a:t> </a:t>
-                      </a:r>
-                      <a:r>
-                        <a:rPr lang="zh-CN" altLang="en-US" dirty="0" smtClean="0"/>
-                        <a:t>它没有考虑</a:t>
+                        <a:t> 它没有考虑</a:t>
                       </a:r>
                       <a:r>
                         <a:rPr lang="en-US" altLang="zh-CN" dirty="0" smtClean="0"/>
@@ -19105,6 +19174,428 @@
           <a:chExt cx="0" cy="0"/>
         </a:xfrm>
       </p:grpSpPr>
+      <p:graphicFrame>
+        <p:nvGraphicFramePr>
+          <p:cNvPr id="4" name="表格 3"/>
+          <p:cNvGraphicFramePr>
+            <a:graphicFrameLocks noGrp="1"/>
+          </p:cNvGraphicFramePr>
+          <p:nvPr>
+            <p:extLst>
+              <p:ext uri="{D42A27DB-BD31-4B8C-83A1-F6EECF244321}">
+                <p14:modId xmlns:p14="http://schemas.microsoft.com/office/powerpoint/2010/main" val="3072695297"/>
+              </p:ext>
+            </p:extLst>
+          </p:nvPr>
+        </p:nvGraphicFramePr>
+        <p:xfrm>
+          <a:off x="543474" y="2922855"/>
+          <a:ext cx="11416295" cy="3654132"/>
+        </p:xfrm>
+        <a:graphic>
+          <a:graphicData uri="http://schemas.openxmlformats.org/drawingml/2006/table">
+            <a:tbl>
+              <a:tblPr firstRow="1" bandRow="1">
+                <a:tableStyleId>{5C22544A-7EE6-4342-B048-85BDC9FD1C3A}</a:tableStyleId>
+              </a:tblPr>
+              <a:tblGrid>
+                <a:gridCol w="2283259">
+                  <a:extLst>
+                    <a:ext uri="{9D8B030D-6E8A-4147-A177-3AD203B41FA5}">
+                      <a16:colId xmlns:a16="http://schemas.microsoft.com/office/drawing/2014/main" val="2104862403"/>
+                    </a:ext>
+                  </a:extLst>
+                </a:gridCol>
+                <a:gridCol w="2283259">
+                  <a:extLst>
+                    <a:ext uri="{9D8B030D-6E8A-4147-A177-3AD203B41FA5}">
+                      <a16:colId xmlns:a16="http://schemas.microsoft.com/office/drawing/2014/main" val="3631488225"/>
+                    </a:ext>
+                  </a:extLst>
+                </a:gridCol>
+                <a:gridCol w="2283259">
+                  <a:extLst>
+                    <a:ext uri="{9D8B030D-6E8A-4147-A177-3AD203B41FA5}">
+                      <a16:colId xmlns:a16="http://schemas.microsoft.com/office/drawing/2014/main" val="1593399558"/>
+                    </a:ext>
+                  </a:extLst>
+                </a:gridCol>
+                <a:gridCol w="2283259">
+                  <a:extLst>
+                    <a:ext uri="{9D8B030D-6E8A-4147-A177-3AD203B41FA5}">
+                      <a16:colId xmlns:a16="http://schemas.microsoft.com/office/drawing/2014/main" val="3501422813"/>
+                    </a:ext>
+                  </a:extLst>
+                </a:gridCol>
+                <a:gridCol w="2283259">
+                  <a:extLst>
+                    <a:ext uri="{9D8B030D-6E8A-4147-A177-3AD203B41FA5}">
+                      <a16:colId xmlns:a16="http://schemas.microsoft.com/office/drawing/2014/main" val="4053707825"/>
+                    </a:ext>
+                  </a:extLst>
+                </a:gridCol>
+              </a:tblGrid>
+              <a:tr h="684538">
+                <a:tc>
+                  <a:txBody>
+                    <a:bodyPr/>
+                    <a:lstStyle/>
+                    <a:p>
+                      <a:endParaRPr lang="zh-CN" altLang="en-US" dirty="0"/>
+                    </a:p>
+                  </a:txBody>
+                  <a:tcPr/>
+                </a:tc>
+                <a:tc>
+                  <a:txBody>
+                    <a:bodyPr/>
+                    <a:lstStyle/>
+                    <a:p>
+                      <a:r>
+                        <a:rPr lang="zh-CN" altLang="en-US" dirty="0" smtClean="0"/>
+                        <a:t>测量</a:t>
+                      </a:r>
+                      <a:endParaRPr lang="zh-CN" altLang="en-US" dirty="0"/>
+                    </a:p>
+                  </a:txBody>
+                  <a:tcPr/>
+                </a:tc>
+                <a:tc>
+                  <a:txBody>
+                    <a:bodyPr/>
+                    <a:lstStyle/>
+                    <a:p>
+                      <a:r>
+                        <a:rPr lang="zh-CN" altLang="en-US" dirty="0" smtClean="0"/>
+                        <a:t>调整</a:t>
+                      </a:r>
+                      <a:endParaRPr lang="zh-CN" altLang="en-US" dirty="0"/>
+                    </a:p>
+                  </a:txBody>
+                  <a:tcPr/>
+                </a:tc>
+                <a:tc>
+                  <a:txBody>
+                    <a:bodyPr/>
+                    <a:lstStyle/>
+                    <a:p>
+                      <a:r>
+                        <a:rPr lang="zh-CN" altLang="en-US" dirty="0" smtClean="0"/>
+                        <a:t>报告</a:t>
+                      </a:r>
+                      <a:endParaRPr lang="zh-CN" altLang="en-US" dirty="0"/>
+                    </a:p>
+                  </a:txBody>
+                  <a:tcPr/>
+                </a:tc>
+                <a:tc>
+                  <a:txBody>
+                    <a:bodyPr/>
+                    <a:lstStyle/>
+                    <a:p>
+                      <a:r>
+                        <a:rPr lang="zh-CN" altLang="en-US" dirty="0" smtClean="0"/>
+                        <a:t>目标</a:t>
+                      </a:r>
+                      <a:endParaRPr lang="zh-CN" altLang="en-US" dirty="0"/>
+                    </a:p>
+                  </a:txBody>
+                  <a:tcPr/>
+                </a:tc>
+                <a:extLst>
+                  <a:ext uri="{0D108BD9-81ED-4DB2-BD59-A6C34878D82A}">
+                    <a16:rowId xmlns:a16="http://schemas.microsoft.com/office/drawing/2014/main" val="3322635084"/>
+                  </a:ext>
+                </a:extLst>
+              </a:tr>
+              <a:tr h="1212829">
+                <a:tc>
+                  <a:txBody>
+                    <a:bodyPr/>
+                    <a:lstStyle/>
+                    <a:p>
+                      <a:r>
+                        <a:rPr lang="en-US" altLang="zh-CN" dirty="0" smtClean="0"/>
+                        <a:t>agent</a:t>
+                      </a:r>
+                      <a:endParaRPr lang="zh-CN" altLang="en-US" dirty="0"/>
+                    </a:p>
+                  </a:txBody>
+                  <a:tcPr/>
+                </a:tc>
+                <a:tc>
+                  <a:txBody>
+                    <a:bodyPr/>
+                    <a:lstStyle/>
+                    <a:p>
+                      <a:r>
+                        <a:rPr lang="zh-CN" altLang="en-US" dirty="0" smtClean="0"/>
+                        <a:t>梯度噪声规模</a:t>
+                      </a:r>
+                      <a:r>
+                        <a:rPr lang="en-US" altLang="zh-CN" dirty="0" smtClean="0"/>
+                        <a:t>, </a:t>
+                      </a:r>
+                      <a:r>
+                        <a:rPr lang="zh-CN" altLang="en-US" dirty="0" smtClean="0"/>
+                        <a:t>系统吞吐量</a:t>
+                      </a:r>
+                      <a:r>
+                        <a:rPr lang="en-US" altLang="zh-CN" dirty="0" smtClean="0"/>
+                        <a:t>. </a:t>
+                      </a:r>
+                    </a:p>
+                    <a:p>
+                      <a:r>
+                        <a:rPr lang="zh-CN" altLang="en-US" dirty="0" smtClean="0"/>
+                        <a:t>每次迭代的时间</a:t>
+                      </a:r>
+                      <a:r>
+                        <a:rPr lang="en-US" altLang="zh-CN" dirty="0" smtClean="0"/>
+                        <a:t>Titer, </a:t>
+                      </a:r>
+                      <a:r>
+                        <a:rPr lang="zh-CN" altLang="en-US" dirty="0" smtClean="0"/>
+                        <a:t>资源分配</a:t>
+                      </a:r>
+                      <a:r>
+                        <a:rPr lang="en-US" altLang="zh-CN" dirty="0" smtClean="0"/>
+                        <a:t>a, </a:t>
+                      </a:r>
+                      <a:r>
+                        <a:rPr lang="en-US" altLang="zh-CN" dirty="0" err="1" smtClean="0"/>
+                        <a:t>batach</a:t>
+                      </a:r>
+                      <a:r>
+                        <a:rPr lang="en-US" altLang="zh-CN" dirty="0" smtClean="0"/>
+                        <a:t> size m , </a:t>
+                      </a:r>
+                      <a:r>
+                        <a:rPr lang="zh-CN" altLang="en-US" dirty="0" smtClean="0"/>
+                        <a:t>梯度累计步骤</a:t>
+                      </a:r>
+                      <a:r>
+                        <a:rPr lang="en-US" altLang="zh-CN" dirty="0" smtClean="0"/>
+                        <a:t>s</a:t>
+                      </a:r>
+                      <a:endParaRPr lang="zh-CN" altLang="en-US" dirty="0"/>
+                    </a:p>
+                  </a:txBody>
+                  <a:tcPr/>
+                </a:tc>
+                <a:tc>
+                  <a:txBody>
+                    <a:bodyPr/>
+                    <a:lstStyle/>
+                    <a:p>
+                      <a:r>
+                        <a:rPr lang="zh-CN" altLang="en-US" dirty="0" smtClean="0"/>
+                        <a:t>学习率</a:t>
+                      </a:r>
+                      <a:endParaRPr lang="zh-CN" altLang="en-US" dirty="0"/>
+                    </a:p>
+                  </a:txBody>
+                  <a:tcPr/>
+                </a:tc>
+                <a:tc>
+                  <a:txBody>
+                    <a:bodyPr/>
+                    <a:lstStyle/>
+                    <a:p>
+                      <a:r>
+                        <a:rPr lang="zh-CN" altLang="en-US" dirty="0" smtClean="0"/>
+                        <a:t>梯度噪声规模</a:t>
+                      </a:r>
+                      <a:r>
+                        <a:rPr lang="en-US" altLang="zh-CN" dirty="0" smtClean="0"/>
+                        <a:t>, </a:t>
+                      </a:r>
+                      <a:r>
+                        <a:rPr lang="zh-CN" altLang="en-US" dirty="0" smtClean="0"/>
+                        <a:t>系统吞吐量</a:t>
+                      </a:r>
+                      <a:r>
+                        <a:rPr lang="en-US" altLang="zh-CN" dirty="0" smtClean="0"/>
+                        <a:t>. </a:t>
+                      </a:r>
+                    </a:p>
+                    <a:p>
+                      <a:r>
+                        <a:rPr lang="zh-CN" altLang="en-US" dirty="0" smtClean="0"/>
+                        <a:t>拟合的参数</a:t>
+                      </a:r>
+                      <a:r>
+                        <a:rPr lang="en-US" altLang="zh-CN" dirty="0" smtClean="0"/>
+                        <a:t>,</a:t>
+                      </a:r>
+                      <a:endParaRPr lang="en-US" altLang="zh-CN" dirty="0" smtClean="0"/>
+                    </a:p>
+                  </a:txBody>
+                  <a:tcPr/>
+                </a:tc>
+                <a:tc>
+                  <a:txBody>
+                    <a:bodyPr/>
+                    <a:lstStyle/>
+                    <a:p>
+                      <a:pPr marL="0" marR="0" indent="0" algn="l" defTabSz="914400" rtl="0" eaLnBrk="1" fontAlgn="auto" latinLnBrk="0" hangingPunct="1">
+                        <a:lnSpc>
+                          <a:spcPct val="100000"/>
+                        </a:lnSpc>
+                        <a:spcBef>
+                          <a:spcPts val="0"/>
+                        </a:spcBef>
+                        <a:spcAft>
+                          <a:spcPts val="0"/>
+                        </a:spcAft>
+                        <a:buClrTx/>
+                        <a:buSzTx/>
+                        <a:buFontTx/>
+                        <a:buNone/>
+                        <a:tabLst/>
+                        <a:defRPr/>
+                      </a:pPr>
+                      <a:r>
+                        <a:rPr lang="zh-CN" altLang="en-US" dirty="0" smtClean="0"/>
+                        <a:t>找到最好的 </a:t>
+                      </a:r>
+                      <a:r>
+                        <a:rPr lang="en-US" altLang="zh-CN" dirty="0" smtClean="0"/>
+                        <a:t>batch size</a:t>
+                      </a:r>
+                      <a:r>
+                        <a:rPr lang="zh-CN" altLang="en-US" dirty="0" smtClean="0"/>
+                        <a:t>和</a:t>
+                      </a:r>
+                      <a:r>
+                        <a:rPr lang="zh-CN" altLang="en-US" dirty="0" smtClean="0"/>
+                        <a:t>梯度累计步骤</a:t>
+                      </a:r>
+                      <a:r>
+                        <a:rPr lang="en-US" altLang="zh-CN" dirty="0" smtClean="0"/>
+                        <a:t>s</a:t>
+                      </a:r>
+                      <a:endParaRPr lang="zh-CN" altLang="en-US" dirty="0" smtClean="0"/>
+                    </a:p>
+                    <a:p>
+                      <a:endParaRPr lang="zh-CN" altLang="en-US" dirty="0"/>
+                    </a:p>
+                  </a:txBody>
+                  <a:tcPr/>
+                </a:tc>
+                <a:extLst>
+                  <a:ext uri="{0D108BD9-81ED-4DB2-BD59-A6C34878D82A}">
+                    <a16:rowId xmlns:a16="http://schemas.microsoft.com/office/drawing/2014/main" val="4110064030"/>
+                  </a:ext>
+                </a:extLst>
+              </a:tr>
+              <a:tr h="1232234">
+                <a:tc>
+                  <a:txBody>
+                    <a:bodyPr/>
+                    <a:lstStyle/>
+                    <a:p>
+                      <a:r>
+                        <a:rPr lang="en-US" altLang="zh-CN" dirty="0" smtClean="0"/>
+                        <a:t>scheduler</a:t>
+                      </a:r>
+                      <a:endParaRPr lang="zh-CN" altLang="en-US" dirty="0"/>
+                    </a:p>
+                  </a:txBody>
+                  <a:tcPr/>
+                </a:tc>
+                <a:tc>
+                  <a:txBody>
+                    <a:bodyPr/>
+                    <a:lstStyle/>
+                    <a:p>
+                      <a:endParaRPr lang="zh-CN" altLang="en-US" dirty="0"/>
+                    </a:p>
+                  </a:txBody>
+                  <a:tcPr/>
+                </a:tc>
+                <a:tc>
+                  <a:txBody>
+                    <a:bodyPr/>
+                    <a:lstStyle/>
+                    <a:p>
+                      <a:endParaRPr lang="zh-CN" altLang="en-US" dirty="0"/>
+                    </a:p>
+                  </a:txBody>
+                  <a:tcPr/>
+                </a:tc>
+                <a:tc>
+                  <a:txBody>
+                    <a:bodyPr/>
+                    <a:lstStyle/>
+                    <a:p>
+                      <a:endParaRPr lang="zh-CN" altLang="en-US"/>
+                    </a:p>
+                  </a:txBody>
+                  <a:tcPr/>
+                </a:tc>
+                <a:tc>
+                  <a:txBody>
+                    <a:bodyPr/>
+                    <a:lstStyle/>
+                    <a:p>
+                      <a:r>
+                        <a:rPr lang="zh-CN" altLang="en-US" sz="1800" b="0" i="0" kern="1200" smtClean="0">
+                          <a:solidFill>
+                            <a:schemeClr val="dk1"/>
+                          </a:solidFill>
+                          <a:effectLst/>
+                          <a:latin typeface="+mn-lt"/>
+                          <a:ea typeface="+mn-ea"/>
+                          <a:cs typeface="+mn-cs"/>
+                        </a:rPr>
+                        <a:t>最大化适应度函数</a:t>
+                      </a:r>
+                      <a:endParaRPr lang="zh-CN" altLang="en-US" dirty="0"/>
+                    </a:p>
+                  </a:txBody>
+                  <a:tcPr/>
+                </a:tc>
+                <a:extLst>
+                  <a:ext uri="{0D108BD9-81ED-4DB2-BD59-A6C34878D82A}">
+                    <a16:rowId xmlns:a16="http://schemas.microsoft.com/office/drawing/2014/main" val="487215583"/>
+                  </a:ext>
+                </a:extLst>
+              </a:tr>
+            </a:tbl>
+          </a:graphicData>
+        </a:graphic>
+      </p:graphicFrame>
+    </p:spTree>
+    <p:extLst>
+      <p:ext uri="{BB962C8B-B14F-4D97-AF65-F5344CB8AC3E}">
+        <p14:creationId xmlns:p14="http://schemas.microsoft.com/office/powerpoint/2010/main" val="4071331810"/>
+      </p:ext>
+    </p:extLst>
+  </p:cSld>
+  <p:clrMapOvr>
+    <a:masterClrMapping/>
+  </p:clrMapOvr>
+</p:sld>
+</file>
+
+<file path=ppt/slides/slide8.xml><?xml version="1.0" encoding="utf-8"?>
+<p:sld xmlns:a="http://schemas.openxmlformats.org/drawingml/2006/main" xmlns:r="http://schemas.openxmlformats.org/officeDocument/2006/relationships" xmlns:p="http://schemas.openxmlformats.org/presentationml/2006/main">
+  <p:cSld>
+    <p:spTree>
+      <p:nvGrpSpPr>
+        <p:cNvPr id="1" name=""/>
+        <p:cNvGrpSpPr/>
+        <p:nvPr/>
+      </p:nvGrpSpPr>
+      <p:grpSpPr>
+        <a:xfrm>
+          <a:off x="0" y="0"/>
+          <a:ext cx="0" cy="0"/>
+          <a:chOff x="0" y="0"/>
+          <a:chExt cx="0" cy="0"/>
+        </a:xfrm>
+      </p:grpSpPr>
       <p:sp>
         <p:nvSpPr>
           <p:cNvPr id="2" name="标题 1"/>
@@ -19184,7 +19675,7 @@
 </p:sld>
 </file>
 
-<file path=ppt/slides/slide8.xml><?xml version="1.0" encoding="utf-8"?>
+<file path=ppt/slides/slide9.xml><?xml version="1.0" encoding="utf-8"?>
 <p:sld xmlns:a="http://schemas.openxmlformats.org/drawingml/2006/main" xmlns:r="http://schemas.openxmlformats.org/officeDocument/2006/relationships" xmlns:p="http://schemas.openxmlformats.org/presentationml/2006/main">
   <p:cSld>
     <p:spTree>

</xml_diff>

<commit_message>
tomorrow pollux ppt,  scheduler
</commit_message>
<xml_diff>
--- a/week report/8.18 report.pptx
+++ b/week report/8.18 report.pptx
@@ -5,7 +5,7 @@
     <p:sldMasterId id="2147483648" r:id="rId1"/>
   </p:sldMasterIdLst>
   <p:notesMasterIdLst>
-    <p:notesMasterId r:id="rId14"/>
+    <p:notesMasterId r:id="rId13"/>
   </p:notesMasterIdLst>
   <p:sldIdLst>
     <p:sldId id="263" r:id="rId2"/>
@@ -15,11 +15,10 @@
     <p:sldId id="277" r:id="rId6"/>
     <p:sldId id="278" r:id="rId7"/>
     <p:sldId id="279" r:id="rId8"/>
-    <p:sldId id="280" r:id="rId9"/>
-    <p:sldId id="282" r:id="rId10"/>
-    <p:sldId id="281" r:id="rId11"/>
-    <p:sldId id="264" r:id="rId12"/>
-    <p:sldId id="273" r:id="rId13"/>
+    <p:sldId id="282" r:id="rId9"/>
+    <p:sldId id="281" r:id="rId10"/>
+    <p:sldId id="264" r:id="rId11"/>
+    <p:sldId id="273" r:id="rId12"/>
   </p:sldIdLst>
   <p:sldSz cx="12192000" cy="6858000"/>
   <p:notesSz cx="6858000" cy="9144000"/>
@@ -208,7 +207,7 @@
           <a:p>
             <a:fld id="{F4BC8E43-2426-4AB4-B1DA-94A32D613D40}" type="datetimeFigureOut">
               <a:rPr lang="zh-CN" altLang="en-US" smtClean="0"/>
-              <a:t>2021/8/15</a:t>
+              <a:t>2021/8/16</a:t>
             </a:fld>
             <a:endParaRPr lang="zh-CN" altLang="en-US"/>
           </a:p>
@@ -560,90 +559,6 @@
 </p:notes>
 </file>
 
-<file path=ppt/notesSlides/notesSlide10.xml><?xml version="1.0" encoding="utf-8"?>
-<p:notes xmlns:a="http://schemas.openxmlformats.org/drawingml/2006/main" xmlns:r="http://schemas.openxmlformats.org/officeDocument/2006/relationships" xmlns:p="http://schemas.openxmlformats.org/presentationml/2006/main">
-  <p:cSld>
-    <p:spTree>
-      <p:nvGrpSpPr>
-        <p:cNvPr id="1" name=""/>
-        <p:cNvGrpSpPr/>
-        <p:nvPr/>
-      </p:nvGrpSpPr>
-      <p:grpSpPr>
-        <a:xfrm>
-          <a:off x="0" y="0"/>
-          <a:ext cx="0" cy="0"/>
-          <a:chOff x="0" y="0"/>
-          <a:chExt cx="0" cy="0"/>
-        </a:xfrm>
-      </p:grpSpPr>
-      <p:sp>
-        <p:nvSpPr>
-          <p:cNvPr id="2" name="幻灯片图像占位符 1"/>
-          <p:cNvSpPr>
-            <a:spLocks noGrp="1" noRot="1" noChangeAspect="1"/>
-          </p:cNvSpPr>
-          <p:nvPr>
-            <p:ph type="sldImg"/>
-          </p:nvPr>
-        </p:nvSpPr>
-        <p:spPr/>
-      </p:sp>
-      <p:sp>
-        <p:nvSpPr>
-          <p:cNvPr id="3" name="备注占位符 2"/>
-          <p:cNvSpPr>
-            <a:spLocks noGrp="1"/>
-          </p:cNvSpPr>
-          <p:nvPr>
-            <p:ph type="body" idx="1"/>
-          </p:nvPr>
-        </p:nvSpPr>
-        <p:spPr/>
-        <p:txBody>
-          <a:bodyPr/>
-          <a:lstStyle/>
-          <a:p>
-            <a:endParaRPr lang="zh-CN" altLang="en-US" dirty="0"/>
-          </a:p>
-        </p:txBody>
-      </p:sp>
-      <p:sp>
-        <p:nvSpPr>
-          <p:cNvPr id="4" name="灯片编号占位符 3"/>
-          <p:cNvSpPr>
-            <a:spLocks noGrp="1"/>
-          </p:cNvSpPr>
-          <p:nvPr>
-            <p:ph type="sldNum" sz="quarter" idx="10"/>
-          </p:nvPr>
-        </p:nvSpPr>
-        <p:spPr/>
-        <p:txBody>
-          <a:bodyPr/>
-          <a:lstStyle/>
-          <a:p>
-            <a:fld id="{5CF06ACB-586E-4135-A9BA-C2B440FB252A}" type="slidenum">
-              <a:rPr lang="zh-CN" altLang="en-US" smtClean="0"/>
-              <a:t>11</a:t>
-            </a:fld>
-            <a:endParaRPr lang="zh-CN" altLang="en-US"/>
-          </a:p>
-        </p:txBody>
-      </p:sp>
-    </p:spTree>
-    <p:extLst>
-      <p:ext uri="{BB962C8B-B14F-4D97-AF65-F5344CB8AC3E}">
-        <p14:creationId xmlns:p14="http://schemas.microsoft.com/office/powerpoint/2010/main" val="246271451"/>
-      </p:ext>
-    </p:extLst>
-  </p:cSld>
-  <p:clrMapOvr>
-    <a:masterClrMapping/>
-  </p:clrMapOvr>
-</p:notes>
-</file>
-
 <file path=ppt/notesSlides/notesSlide2.xml><?xml version="1.0" encoding="utf-8"?>
 <p:notes xmlns:a="http://schemas.openxmlformats.org/drawingml/2006/main" xmlns:r="http://schemas.openxmlformats.org/officeDocument/2006/relationships" xmlns:p="http://schemas.openxmlformats.org/presentationml/2006/main">
   <p:cSld>
@@ -1174,7 +1089,7 @@
     </p:spTree>
     <p:extLst>
       <p:ext uri="{BB962C8B-B14F-4D97-AF65-F5344CB8AC3E}">
-        <p14:creationId xmlns:p14="http://schemas.microsoft.com/office/powerpoint/2010/main" val="1451267136"/>
+        <p14:creationId xmlns:p14="http://schemas.microsoft.com/office/powerpoint/2010/main" val="2879538242"/>
       </p:ext>
     </p:extLst>
   </p:cSld>
@@ -1258,7 +1173,7 @@
     </p:spTree>
     <p:extLst>
       <p:ext uri="{BB962C8B-B14F-4D97-AF65-F5344CB8AC3E}">
-        <p14:creationId xmlns:p14="http://schemas.microsoft.com/office/powerpoint/2010/main" val="1233359653"/>
+        <p14:creationId xmlns:p14="http://schemas.microsoft.com/office/powerpoint/2010/main" val="3569001480"/>
       </p:ext>
     </p:extLst>
   </p:cSld>
@@ -1342,7 +1257,7 @@
     </p:spTree>
     <p:extLst>
       <p:ext uri="{BB962C8B-B14F-4D97-AF65-F5344CB8AC3E}">
-        <p14:creationId xmlns:p14="http://schemas.microsoft.com/office/powerpoint/2010/main" val="3569001480"/>
+        <p14:creationId xmlns:p14="http://schemas.microsoft.com/office/powerpoint/2010/main" val="246271451"/>
       </p:ext>
     </p:extLst>
   </p:cSld>
@@ -1483,7 +1398,7 @@
           <a:p>
             <a:fld id="{DCC080BC-FD8F-4BC7-912D-250C973482EE}" type="datetimeFigureOut">
               <a:rPr lang="zh-CN" altLang="en-US" smtClean="0"/>
-              <a:t>2021/8/15</a:t>
+              <a:t>2021/8/16</a:t>
             </a:fld>
             <a:endParaRPr lang="zh-CN" altLang="en-US"/>
           </a:p>
@@ -1653,7 +1568,7 @@
           <a:p>
             <a:fld id="{DCC080BC-FD8F-4BC7-912D-250C973482EE}" type="datetimeFigureOut">
               <a:rPr lang="zh-CN" altLang="en-US" smtClean="0"/>
-              <a:t>2021/8/15</a:t>
+              <a:t>2021/8/16</a:t>
             </a:fld>
             <a:endParaRPr lang="zh-CN" altLang="en-US"/>
           </a:p>
@@ -1833,7 +1748,7 @@
           <a:p>
             <a:fld id="{DCC080BC-FD8F-4BC7-912D-250C973482EE}" type="datetimeFigureOut">
               <a:rPr lang="zh-CN" altLang="en-US" smtClean="0"/>
-              <a:t>2021/8/15</a:t>
+              <a:t>2021/8/16</a:t>
             </a:fld>
             <a:endParaRPr lang="zh-CN" altLang="en-US"/>
           </a:p>
@@ -2003,7 +1918,7 @@
           <a:p>
             <a:fld id="{DCC080BC-FD8F-4BC7-912D-250C973482EE}" type="datetimeFigureOut">
               <a:rPr lang="zh-CN" altLang="en-US" smtClean="0"/>
-              <a:t>2021/8/15</a:t>
+              <a:t>2021/8/16</a:t>
             </a:fld>
             <a:endParaRPr lang="zh-CN" altLang="en-US"/>
           </a:p>
@@ -2249,7 +2164,7 @@
           <a:p>
             <a:fld id="{DCC080BC-FD8F-4BC7-912D-250C973482EE}" type="datetimeFigureOut">
               <a:rPr lang="zh-CN" altLang="en-US" smtClean="0"/>
-              <a:t>2021/8/15</a:t>
+              <a:t>2021/8/16</a:t>
             </a:fld>
             <a:endParaRPr lang="zh-CN" altLang="en-US"/>
           </a:p>
@@ -2481,7 +2396,7 @@
           <a:p>
             <a:fld id="{DCC080BC-FD8F-4BC7-912D-250C973482EE}" type="datetimeFigureOut">
               <a:rPr lang="zh-CN" altLang="en-US" smtClean="0"/>
-              <a:t>2021/8/15</a:t>
+              <a:t>2021/8/16</a:t>
             </a:fld>
             <a:endParaRPr lang="zh-CN" altLang="en-US"/>
           </a:p>
@@ -2848,7 +2763,7 @@
           <a:p>
             <a:fld id="{DCC080BC-FD8F-4BC7-912D-250C973482EE}" type="datetimeFigureOut">
               <a:rPr lang="zh-CN" altLang="en-US" smtClean="0"/>
-              <a:t>2021/8/15</a:t>
+              <a:t>2021/8/16</a:t>
             </a:fld>
             <a:endParaRPr lang="zh-CN" altLang="en-US"/>
           </a:p>
@@ -2966,7 +2881,7 @@
           <a:p>
             <a:fld id="{DCC080BC-FD8F-4BC7-912D-250C973482EE}" type="datetimeFigureOut">
               <a:rPr lang="zh-CN" altLang="en-US" smtClean="0"/>
-              <a:t>2021/8/15</a:t>
+              <a:t>2021/8/16</a:t>
             </a:fld>
             <a:endParaRPr lang="zh-CN" altLang="en-US"/>
           </a:p>
@@ -3061,7 +2976,7 @@
           <a:p>
             <a:fld id="{DCC080BC-FD8F-4BC7-912D-250C973482EE}" type="datetimeFigureOut">
               <a:rPr lang="zh-CN" altLang="en-US" smtClean="0"/>
-              <a:t>2021/8/15</a:t>
+              <a:t>2021/8/16</a:t>
             </a:fld>
             <a:endParaRPr lang="zh-CN" altLang="en-US"/>
           </a:p>
@@ -3338,7 +3253,7 @@
           <a:p>
             <a:fld id="{DCC080BC-FD8F-4BC7-912D-250C973482EE}" type="datetimeFigureOut">
               <a:rPr lang="zh-CN" altLang="en-US" smtClean="0"/>
-              <a:t>2021/8/15</a:t>
+              <a:t>2021/8/16</a:t>
             </a:fld>
             <a:endParaRPr lang="zh-CN" altLang="en-US"/>
           </a:p>
@@ -3591,7 +3506,7 @@
           <a:p>
             <a:fld id="{DCC080BC-FD8F-4BC7-912D-250C973482EE}" type="datetimeFigureOut">
               <a:rPr lang="zh-CN" altLang="en-US" smtClean="0"/>
-              <a:t>2021/8/15</a:t>
+              <a:t>2021/8/16</a:t>
             </a:fld>
             <a:endParaRPr lang="zh-CN" altLang="en-US"/>
           </a:p>
@@ -3804,7 +3719,7 @@
           <a:p>
             <a:fld id="{DCC080BC-FD8F-4BC7-912D-250C973482EE}" type="datetimeFigureOut">
               <a:rPr lang="zh-CN" altLang="en-US" smtClean="0"/>
-              <a:t>2021/8/15</a:t>
+              <a:t>2021/8/16</a:t>
             </a:fld>
             <a:endParaRPr lang="zh-CN" altLang="en-US"/>
           </a:p>
@@ -16910,7 +16825,7 @@
           <a:p>
             <a:fld id="{7E66CBCB-337D-49B6-B73D-DC76D0E029C4}" type="datetime1">
               <a:rPr lang="zh-CN" altLang="en-US" smtClean="0"/>
-              <a:t>2021/8/15</a:t>
+              <a:t>2021/8/16</a:t>
             </a:fld>
             <a:endParaRPr lang="zh-CN" altLang="en-US" dirty="0"/>
           </a:p>
@@ -16978,43 +16893,22 @@
       </p:grpSpPr>
       <p:sp>
         <p:nvSpPr>
-          <p:cNvPr id="4" name="矩形 3"/>
-          <p:cNvSpPr/>
-          <p:nvPr/>
+          <p:cNvPr id="2" name="标题 1"/>
+          <p:cNvSpPr>
+            <a:spLocks noGrp="1"/>
+          </p:cNvSpPr>
+          <p:nvPr>
+            <p:ph type="title"/>
+          </p:nvPr>
         </p:nvSpPr>
-        <p:spPr>
-          <a:xfrm>
-            <a:off x="2621879" y="805794"/>
-            <a:ext cx="803563" cy="609167"/>
-          </a:xfrm>
-          <a:prstGeom prst="rect">
-            <a:avLst/>
-          </a:prstGeom>
-        </p:spPr>
-        <p:style>
-          <a:lnRef idx="2">
-            <a:schemeClr val="accent1">
-              <a:shade val="50000"/>
-            </a:schemeClr>
-          </a:lnRef>
-          <a:fillRef idx="1">
-            <a:schemeClr val="accent1"/>
-          </a:fillRef>
-          <a:effectRef idx="0">
-            <a:schemeClr val="accent1"/>
-          </a:effectRef>
-          <a:fontRef idx="minor">
-            <a:schemeClr val="lt1"/>
-          </a:fontRef>
-        </p:style>
+        <p:spPr/>
         <p:txBody>
-          <a:bodyPr rtlCol="0" anchor="ctr"/>
+          <a:bodyPr/>
           <a:lstStyle/>
           <a:p>
-            <a:pPr algn="ctr"/>
             <a:r>
-              <a:rPr lang="en-US" altLang="zh-CN" dirty="0" smtClean="0"/>
-              <a:t>CPU0</a:t>
+              <a:rPr lang="zh-CN" altLang="en-US" dirty="0" smtClean="0"/>
+              <a:t>问老师的问题</a:t>
             </a:r>
             <a:endParaRPr lang="zh-CN" altLang="en-US" dirty="0"/>
           </a:p>
@@ -17022,1274 +16916,51 @@
       </p:sp>
       <p:sp>
         <p:nvSpPr>
-          <p:cNvPr id="6" name="矩形 5"/>
-          <p:cNvSpPr/>
-          <p:nvPr/>
+          <p:cNvPr id="3" name="内容占位符 2"/>
+          <p:cNvSpPr>
+            <a:spLocks noGrp="1"/>
+          </p:cNvSpPr>
+          <p:nvPr>
+            <p:ph idx="1"/>
+          </p:nvPr>
         </p:nvSpPr>
-        <p:spPr>
-          <a:xfrm>
-            <a:off x="1328949" y="851575"/>
-            <a:ext cx="803563" cy="536170"/>
-          </a:xfrm>
-          <a:prstGeom prst="rect">
-            <a:avLst/>
-          </a:prstGeom>
-        </p:spPr>
-        <p:style>
-          <a:lnRef idx="2">
-            <a:schemeClr val="accent1">
-              <a:shade val="50000"/>
-            </a:schemeClr>
-          </a:lnRef>
-          <a:fillRef idx="1">
-            <a:schemeClr val="accent1"/>
-          </a:fillRef>
-          <a:effectRef idx="0">
-            <a:schemeClr val="accent1"/>
-          </a:effectRef>
-          <a:fontRef idx="minor">
-            <a:schemeClr val="lt1"/>
-          </a:fontRef>
-        </p:style>
+        <p:spPr/>
         <p:txBody>
-          <a:bodyPr rtlCol="0" anchor="ctr"/>
-          <a:lstStyle/>
-          <a:p>
-            <a:pPr algn="ctr"/>
-            <a:endParaRPr lang="zh-CN" altLang="en-US" dirty="0"/>
-          </a:p>
-        </p:txBody>
-      </p:sp>
-      <p:sp>
-        <p:nvSpPr>
-          <p:cNvPr id="7" name="文本框 6"/>
-          <p:cNvSpPr txBox="1"/>
-          <p:nvPr/>
-        </p:nvSpPr>
-        <p:spPr>
-          <a:xfrm>
-            <a:off x="1051957" y="528893"/>
-            <a:ext cx="1183337" cy="369332"/>
-          </a:xfrm>
-          <a:prstGeom prst="rect">
-            <a:avLst/>
-          </a:prstGeom>
-          <a:noFill/>
-        </p:spPr>
-        <p:txBody>
-          <a:bodyPr wrap="none" rtlCol="0">
-            <a:spAutoFit/>
+          <a:bodyPr>
+            <a:normAutofit/>
           </a:bodyPr>
           <a:lstStyle/>
           <a:p>
-            <a:r>
-              <a:rPr lang="en-US" altLang="zh-CN" dirty="0" smtClean="0"/>
-              <a:t>CPU Mem</a:t>
-            </a:r>
-            <a:endParaRPr lang="zh-CN" altLang="en-US" dirty="0"/>
-          </a:p>
-        </p:txBody>
-      </p:sp>
-      <p:sp>
-        <p:nvSpPr>
-          <p:cNvPr id="8" name="矩形 7"/>
-          <p:cNvSpPr/>
-          <p:nvPr/>
-        </p:nvSpPr>
-        <p:spPr>
-          <a:xfrm>
-            <a:off x="2599777" y="2756440"/>
-            <a:ext cx="803563" cy="609167"/>
-          </a:xfrm>
-          <a:prstGeom prst="rect">
-            <a:avLst/>
-          </a:prstGeom>
-        </p:spPr>
-        <p:style>
-          <a:lnRef idx="2">
-            <a:schemeClr val="accent1">
-              <a:shade val="50000"/>
-            </a:schemeClr>
-          </a:lnRef>
-          <a:fillRef idx="1">
-            <a:schemeClr val="accent1"/>
-          </a:fillRef>
-          <a:effectRef idx="0">
-            <a:schemeClr val="accent1"/>
-          </a:effectRef>
-          <a:fontRef idx="minor">
-            <a:schemeClr val="lt1"/>
-          </a:fontRef>
-        </p:style>
-        <p:txBody>
-          <a:bodyPr rtlCol="0" anchor="ctr"/>
-          <a:lstStyle/>
-          <a:p>
-            <a:pPr algn="ctr"/>
-            <a:r>
-              <a:rPr lang="en-US" altLang="zh-CN" dirty="0" smtClean="0"/>
-              <a:t>CPU1</a:t>
-            </a:r>
-            <a:endParaRPr lang="zh-CN" altLang="en-US" dirty="0"/>
-          </a:p>
-        </p:txBody>
-      </p:sp>
-      <p:sp>
-        <p:nvSpPr>
-          <p:cNvPr id="9" name="矩形 8"/>
-          <p:cNvSpPr/>
-          <p:nvPr/>
-        </p:nvSpPr>
-        <p:spPr>
-          <a:xfrm>
-            <a:off x="1597872" y="2817272"/>
-            <a:ext cx="803563" cy="536170"/>
-          </a:xfrm>
-          <a:prstGeom prst="rect">
-            <a:avLst/>
-          </a:prstGeom>
-        </p:spPr>
-        <p:style>
-          <a:lnRef idx="2">
-            <a:schemeClr val="accent1">
-              <a:shade val="50000"/>
-            </a:schemeClr>
-          </a:lnRef>
-          <a:fillRef idx="1">
-            <a:schemeClr val="accent1"/>
-          </a:fillRef>
-          <a:effectRef idx="0">
-            <a:schemeClr val="accent1"/>
-          </a:effectRef>
-          <a:fontRef idx="minor">
-            <a:schemeClr val="lt1"/>
-          </a:fontRef>
-        </p:style>
-        <p:txBody>
-          <a:bodyPr rtlCol="0" anchor="ctr"/>
-          <a:lstStyle/>
-          <a:p>
-            <a:pPr algn="ctr"/>
-            <a:endParaRPr lang="zh-CN" altLang="en-US" dirty="0"/>
-          </a:p>
-        </p:txBody>
-      </p:sp>
-      <p:sp>
-        <p:nvSpPr>
-          <p:cNvPr id="10" name="文本框 9"/>
-          <p:cNvSpPr txBox="1"/>
-          <p:nvPr/>
-        </p:nvSpPr>
-        <p:spPr>
-          <a:xfrm>
-            <a:off x="1223881" y="2460104"/>
-            <a:ext cx="1183337" cy="369332"/>
-          </a:xfrm>
-          <a:prstGeom prst="rect">
-            <a:avLst/>
-          </a:prstGeom>
-          <a:noFill/>
-        </p:spPr>
-        <p:txBody>
-          <a:bodyPr wrap="none" rtlCol="0">
-            <a:spAutoFit/>
-          </a:bodyPr>
-          <a:lstStyle/>
-          <a:p>
-            <a:r>
-              <a:rPr lang="en-US" altLang="zh-CN" dirty="0" smtClean="0"/>
-              <a:t>CPU Mem</a:t>
-            </a:r>
-            <a:endParaRPr lang="zh-CN" altLang="en-US" dirty="0"/>
-          </a:p>
-        </p:txBody>
-      </p:sp>
-      <p:sp>
-        <p:nvSpPr>
-          <p:cNvPr id="11" name="矩形 10"/>
-          <p:cNvSpPr/>
-          <p:nvPr/>
-        </p:nvSpPr>
-        <p:spPr>
-          <a:xfrm>
-            <a:off x="3883351" y="767670"/>
-            <a:ext cx="803563" cy="609167"/>
-          </a:xfrm>
-          <a:prstGeom prst="rect">
-            <a:avLst/>
-          </a:prstGeom>
-        </p:spPr>
-        <p:style>
-          <a:lnRef idx="2">
-            <a:schemeClr val="accent1">
-              <a:shade val="50000"/>
-            </a:schemeClr>
-          </a:lnRef>
-          <a:fillRef idx="1">
-            <a:schemeClr val="accent1"/>
-          </a:fillRef>
-          <a:effectRef idx="0">
-            <a:schemeClr val="accent1"/>
-          </a:effectRef>
-          <a:fontRef idx="minor">
-            <a:schemeClr val="lt1"/>
-          </a:fontRef>
-        </p:style>
-        <p:txBody>
-          <a:bodyPr rtlCol="0" anchor="ctr"/>
-          <a:lstStyle/>
-          <a:p>
-            <a:pPr algn="ctr"/>
-            <a:r>
-              <a:rPr lang="en-US" altLang="zh-CN" dirty="0" smtClean="0"/>
-              <a:t>GPU0</a:t>
-            </a:r>
-            <a:endParaRPr lang="zh-CN" altLang="en-US" dirty="0"/>
-          </a:p>
-        </p:txBody>
-      </p:sp>
-      <p:sp>
-        <p:nvSpPr>
-          <p:cNvPr id="12" name="矩形 11"/>
-          <p:cNvSpPr/>
-          <p:nvPr/>
-        </p:nvSpPr>
-        <p:spPr>
-          <a:xfrm>
-            <a:off x="5002206" y="767670"/>
-            <a:ext cx="803563" cy="609167"/>
-          </a:xfrm>
-          <a:prstGeom prst="rect">
-            <a:avLst/>
-          </a:prstGeom>
-        </p:spPr>
-        <p:style>
-          <a:lnRef idx="2">
-            <a:schemeClr val="accent1">
-              <a:shade val="50000"/>
-            </a:schemeClr>
-          </a:lnRef>
-          <a:fillRef idx="1">
-            <a:schemeClr val="accent1"/>
-          </a:fillRef>
-          <a:effectRef idx="0">
-            <a:schemeClr val="accent1"/>
-          </a:effectRef>
-          <a:fontRef idx="minor">
-            <a:schemeClr val="lt1"/>
-          </a:fontRef>
-        </p:style>
-        <p:txBody>
-          <a:bodyPr rtlCol="0" anchor="ctr"/>
-          <a:lstStyle/>
-          <a:p>
-            <a:pPr algn="ctr"/>
-            <a:endParaRPr lang="zh-CN" altLang="en-US" dirty="0"/>
-          </a:p>
-        </p:txBody>
-      </p:sp>
-      <p:sp>
-        <p:nvSpPr>
-          <p:cNvPr id="13" name="文本框 12"/>
-          <p:cNvSpPr txBox="1"/>
-          <p:nvPr/>
-        </p:nvSpPr>
-        <p:spPr>
-          <a:xfrm>
-            <a:off x="4805908" y="398338"/>
-            <a:ext cx="1196161" cy="369332"/>
-          </a:xfrm>
-          <a:prstGeom prst="rect">
-            <a:avLst/>
-          </a:prstGeom>
-          <a:noFill/>
-        </p:spPr>
-        <p:txBody>
-          <a:bodyPr wrap="none" rtlCol="0">
-            <a:spAutoFit/>
-          </a:bodyPr>
-          <a:lstStyle/>
-          <a:p>
-            <a:r>
-              <a:rPr lang="en-US" altLang="zh-CN" dirty="0"/>
-              <a:t>G</a:t>
-            </a:r>
-            <a:r>
-              <a:rPr lang="en-US" altLang="zh-CN" dirty="0" smtClean="0"/>
-              <a:t>PU Mem</a:t>
-            </a:r>
-            <a:endParaRPr lang="zh-CN" altLang="en-US" dirty="0"/>
-          </a:p>
-        </p:txBody>
-      </p:sp>
-      <p:sp>
-        <p:nvSpPr>
-          <p:cNvPr id="14" name="矩形 13"/>
-          <p:cNvSpPr/>
-          <p:nvPr/>
-        </p:nvSpPr>
-        <p:spPr>
-          <a:xfrm>
-            <a:off x="3883351" y="2747141"/>
-            <a:ext cx="803563" cy="609167"/>
-          </a:xfrm>
-          <a:prstGeom prst="rect">
-            <a:avLst/>
-          </a:prstGeom>
-        </p:spPr>
-        <p:style>
-          <a:lnRef idx="2">
-            <a:schemeClr val="accent1">
-              <a:shade val="50000"/>
-            </a:schemeClr>
-          </a:lnRef>
-          <a:fillRef idx="1">
-            <a:schemeClr val="accent1"/>
-          </a:fillRef>
-          <a:effectRef idx="0">
-            <a:schemeClr val="accent1"/>
-          </a:effectRef>
-          <a:fontRef idx="minor">
-            <a:schemeClr val="lt1"/>
-          </a:fontRef>
-        </p:style>
-        <p:txBody>
-          <a:bodyPr rtlCol="0" anchor="ctr"/>
-          <a:lstStyle/>
-          <a:p>
-            <a:pPr algn="ctr"/>
-            <a:r>
-              <a:rPr lang="en-US" altLang="zh-CN" dirty="0" smtClean="0"/>
-              <a:t>GPU1</a:t>
-            </a:r>
-            <a:endParaRPr lang="zh-CN" altLang="en-US" dirty="0"/>
-          </a:p>
-        </p:txBody>
-      </p:sp>
-      <p:cxnSp>
-        <p:nvCxnSpPr>
-          <p:cNvPr id="18" name="直接箭头连接符 17"/>
-          <p:cNvCxnSpPr>
-            <a:stCxn id="8" idx="3"/>
-            <a:endCxn id="14" idx="1"/>
-          </p:cNvCxnSpPr>
-          <p:nvPr/>
-        </p:nvCxnSpPr>
-        <p:spPr>
-          <a:xfrm flipV="1">
-            <a:off x="3403340" y="3051725"/>
-            <a:ext cx="480011" cy="9299"/>
-          </a:xfrm>
-          <a:prstGeom prst="straightConnector1">
-            <a:avLst/>
-          </a:prstGeom>
-          <a:ln>
-            <a:headEnd type="triangle"/>
-            <a:tailEnd type="triangle"/>
-          </a:ln>
-        </p:spPr>
-        <p:style>
-          <a:lnRef idx="1">
-            <a:schemeClr val="accent1"/>
-          </a:lnRef>
-          <a:fillRef idx="0">
-            <a:schemeClr val="accent1"/>
-          </a:fillRef>
-          <a:effectRef idx="0">
-            <a:schemeClr val="accent1"/>
-          </a:effectRef>
-          <a:fontRef idx="minor">
-            <a:schemeClr val="tx1"/>
-          </a:fontRef>
-        </p:style>
-      </p:cxnSp>
-      <p:cxnSp>
-        <p:nvCxnSpPr>
-          <p:cNvPr id="24" name="直接箭头连接符 23"/>
-          <p:cNvCxnSpPr/>
-          <p:nvPr/>
-        </p:nvCxnSpPr>
-        <p:spPr>
-          <a:xfrm>
-            <a:off x="1915080" y="1257383"/>
-            <a:ext cx="2180167" cy="5541"/>
-          </a:xfrm>
-          <a:prstGeom prst="straightConnector1">
-            <a:avLst/>
-          </a:prstGeom>
-          <a:ln>
-            <a:prstDash val="dashDot"/>
-            <a:tailEnd type="triangle"/>
-          </a:ln>
-        </p:spPr>
-        <p:style>
-          <a:lnRef idx="1">
-            <a:schemeClr val="dk1"/>
-          </a:lnRef>
-          <a:fillRef idx="0">
-            <a:schemeClr val="dk1"/>
-          </a:fillRef>
-          <a:effectRef idx="0">
-            <a:schemeClr val="dk1"/>
-          </a:effectRef>
-          <a:fontRef idx="minor">
-            <a:schemeClr val="tx1"/>
-          </a:fontRef>
-        </p:style>
-      </p:cxnSp>
-      <p:sp>
-        <p:nvSpPr>
-          <p:cNvPr id="31" name="文本框 30"/>
-          <p:cNvSpPr txBox="1"/>
-          <p:nvPr/>
-        </p:nvSpPr>
-        <p:spPr>
-          <a:xfrm>
-            <a:off x="3576807" y="1236887"/>
-            <a:ext cx="659155" cy="369332"/>
-          </a:xfrm>
-          <a:prstGeom prst="rect">
-            <a:avLst/>
-          </a:prstGeom>
-          <a:noFill/>
-        </p:spPr>
-        <p:txBody>
-          <a:bodyPr wrap="none" rtlCol="0">
-            <a:spAutoFit/>
-          </a:bodyPr>
-          <a:lstStyle/>
-          <a:p>
-            <a:r>
-              <a:rPr lang="en-US" altLang="zh-CN" dirty="0" smtClean="0"/>
-              <a:t>1</a:t>
-            </a:r>
+            <a:pPr marL="0" lvl="0" indent="0">
+              <a:buNone/>
+            </a:pPr>
             <a:r>
               <a:rPr lang="zh-CN" altLang="en-US" dirty="0" smtClean="0"/>
-              <a:t>或</a:t>
+              <a:t>许多问题已经问了</a:t>
             </a:r>
-            <a:r>
-              <a:rPr lang="en-US" altLang="zh-CN" dirty="0" smtClean="0"/>
-              <a:t>2</a:t>
-            </a:r>
-            <a:endParaRPr lang="zh-CN" altLang="en-US" dirty="0"/>
-          </a:p>
-        </p:txBody>
-      </p:sp>
-      <p:sp>
-        <p:nvSpPr>
-          <p:cNvPr id="32" name="文本框 31"/>
-          <p:cNvSpPr txBox="1"/>
-          <p:nvPr/>
-        </p:nvSpPr>
-        <p:spPr>
-          <a:xfrm>
-            <a:off x="745915" y="3807935"/>
-            <a:ext cx="4501553" cy="4247317"/>
-          </a:xfrm>
-          <a:prstGeom prst="rect">
-            <a:avLst/>
-          </a:prstGeom>
-          <a:noFill/>
-        </p:spPr>
-        <p:txBody>
-          <a:bodyPr wrap="none" rtlCol="0">
-            <a:spAutoFit/>
-          </a:bodyPr>
-          <a:lstStyle/>
-          <a:p>
-            <a:r>
-              <a:rPr lang="en-US" altLang="zh-CN" dirty="0" smtClean="0"/>
-              <a:t>GPU with CPU mem </a:t>
-            </a:r>
-            <a:endParaRPr lang="en-US" altLang="zh-CN" dirty="0"/>
-          </a:p>
-          <a:p>
-            <a:pPr marL="342900" indent="-342900">
-              <a:buAutoNum type="arabicPlain"/>
-            </a:pPr>
-            <a:r>
-              <a:rPr lang="en-US" altLang="zh-CN" dirty="0" smtClean="0"/>
-              <a:t> PCI-e 3.0</a:t>
-            </a:r>
-          </a:p>
-          <a:p>
-            <a:pPr marL="342900" indent="-342900">
-              <a:buAutoNum type="arabicPlain"/>
-            </a:pPr>
             <a:r>
               <a:rPr lang="en-US" altLang="zh-CN" dirty="0" smtClean="0"/>
               <a:t> </a:t>
             </a:r>
             <a:r>
+              <a:rPr lang="en-US" altLang="zh-CN" dirty="0" err="1"/>
+              <a:t>Z</a:t>
+            </a:r>
+            <a:r>
               <a:rPr lang="en-US" altLang="zh-CN" dirty="0" err="1" smtClean="0"/>
-              <a:t>NVLink</a:t>
+              <a:t>iyue</a:t>
             </a:r>
             <a:r>
               <a:rPr lang="en-US" altLang="zh-CN" dirty="0" smtClean="0"/>
-              <a:t> 2.0</a:t>
+              <a:t> Luo</a:t>
             </a:r>
-          </a:p>
-          <a:p>
-            <a:r>
-              <a:rPr lang="en-US" altLang="zh-CN" dirty="0"/>
-              <a:t>CPU interconnects </a:t>
-            </a:r>
-          </a:p>
-          <a:p>
-            <a:r>
-              <a:rPr lang="en-US" altLang="zh-CN" dirty="0" smtClean="0"/>
-              <a:t>3    Intel </a:t>
-            </a:r>
-            <a:r>
-              <a:rPr lang="en-US" altLang="zh-CN" dirty="0"/>
-              <a:t>Xeon Ultra Path Interconnect (UPI</a:t>
-            </a:r>
-            <a:r>
-              <a:rPr lang="en-US" altLang="zh-CN" dirty="0" smtClean="0"/>
-              <a:t>)</a:t>
-            </a:r>
-          </a:p>
-          <a:p>
-            <a:r>
-              <a:rPr lang="en-US" altLang="zh-CN" dirty="0" smtClean="0"/>
-              <a:t>4    IBM </a:t>
-            </a:r>
-            <a:r>
-              <a:rPr lang="en-US" altLang="zh-CN" dirty="0"/>
-              <a:t>POWER9 </a:t>
-            </a:r>
-            <a:r>
-              <a:rPr lang="en-US" altLang="zh-CN" dirty="0" smtClean="0"/>
-              <a:t>X-Bus</a:t>
-            </a:r>
-          </a:p>
-          <a:p>
-            <a:r>
-              <a:rPr lang="en-US" altLang="zh-CN" dirty="0"/>
-              <a:t>CPU memory </a:t>
-            </a:r>
-            <a:endParaRPr lang="en-US" altLang="zh-CN" dirty="0" smtClean="0"/>
-          </a:p>
-          <a:p>
-            <a:r>
-              <a:rPr lang="en-US" altLang="zh-CN" dirty="0" smtClean="0"/>
-              <a:t>5    </a:t>
-            </a:r>
-            <a:r>
-              <a:rPr lang="en-US" altLang="zh-CN" dirty="0" smtClean="0">
-                <a:solidFill>
-                  <a:schemeClr val="dk1"/>
-                </a:solidFill>
-              </a:rPr>
-              <a:t>Intel Xeon</a:t>
-            </a:r>
-            <a:endParaRPr lang="en-US" altLang="zh-CN" dirty="0" smtClean="0"/>
-          </a:p>
-          <a:p>
-            <a:r>
-              <a:rPr lang="en-US" altLang="zh-CN" dirty="0" smtClean="0"/>
-              <a:t>6    </a:t>
-            </a:r>
-            <a:r>
-              <a:rPr lang="en-US" altLang="zh-CN" dirty="0" smtClean="0">
-                <a:solidFill>
-                  <a:schemeClr val="dk1"/>
-                </a:solidFill>
-              </a:rPr>
-              <a:t>IBM </a:t>
-            </a:r>
-            <a:r>
-              <a:rPr lang="en-US" altLang="zh-CN" dirty="0">
-                <a:solidFill>
-                  <a:schemeClr val="dk1"/>
-                </a:solidFill>
-              </a:rPr>
-              <a:t>POWER9</a:t>
-            </a:r>
-            <a:endParaRPr lang="en-US" altLang="zh-CN" dirty="0"/>
-          </a:p>
-          <a:p>
-            <a:r>
-              <a:rPr lang="en-US" altLang="zh-CN" dirty="0" smtClean="0"/>
-              <a:t>7    </a:t>
-            </a:r>
-            <a:r>
-              <a:rPr lang="en-US" altLang="zh-CN" dirty="0" err="1" smtClean="0">
-                <a:solidFill>
-                  <a:schemeClr val="dk1"/>
-                </a:solidFill>
-              </a:rPr>
-              <a:t>Nvidia</a:t>
-            </a:r>
-            <a:r>
-              <a:rPr lang="en-US" altLang="zh-CN" dirty="0" smtClean="0">
-                <a:solidFill>
-                  <a:schemeClr val="dk1"/>
-                </a:solidFill>
-              </a:rPr>
-              <a:t> </a:t>
-            </a:r>
-            <a:r>
-              <a:rPr lang="en-US" altLang="zh-CN" dirty="0">
-                <a:solidFill>
-                  <a:schemeClr val="dk1"/>
-                </a:solidFill>
-              </a:rPr>
-              <a:t>V100</a:t>
-            </a:r>
-            <a:endParaRPr lang="en-US" altLang="zh-CN" dirty="0"/>
-          </a:p>
-          <a:p>
-            <a:endParaRPr lang="en-US" altLang="zh-CN" dirty="0" smtClean="0"/>
-          </a:p>
-          <a:p>
-            <a:endParaRPr lang="en-US" altLang="zh-CN" dirty="0"/>
-          </a:p>
-          <a:p>
-            <a:endParaRPr lang="en-US" altLang="zh-CN" dirty="0" smtClean="0"/>
-          </a:p>
-          <a:p>
-            <a:endParaRPr lang="en-US" altLang="zh-CN" dirty="0" smtClean="0"/>
-          </a:p>
-          <a:p>
-            <a:pPr marL="342900" indent="-342900">
-              <a:buAutoNum type="arabicPlain"/>
-            </a:pPr>
-            <a:endParaRPr lang="zh-CN" altLang="en-US" dirty="0"/>
-          </a:p>
-        </p:txBody>
-      </p:sp>
-      <p:cxnSp>
-        <p:nvCxnSpPr>
-          <p:cNvPr id="40" name="曲线连接符 39"/>
-          <p:cNvCxnSpPr/>
-          <p:nvPr/>
-        </p:nvCxnSpPr>
-        <p:spPr>
-          <a:xfrm flipV="1">
-            <a:off x="2388017" y="1346075"/>
-            <a:ext cx="498157" cy="1840136"/>
-          </a:xfrm>
-          <a:prstGeom prst="curvedConnector2">
-            <a:avLst/>
-          </a:prstGeom>
-          <a:ln>
-            <a:tailEnd type="triangle"/>
-          </a:ln>
-        </p:spPr>
-        <p:style>
-          <a:lnRef idx="1">
-            <a:schemeClr val="dk1"/>
-          </a:lnRef>
-          <a:fillRef idx="0">
-            <a:schemeClr val="dk1"/>
-          </a:fillRef>
-          <a:effectRef idx="0">
-            <a:schemeClr val="dk1"/>
-          </a:effectRef>
-          <a:fontRef idx="minor">
-            <a:schemeClr val="tx1"/>
-          </a:fontRef>
-        </p:style>
-      </p:cxnSp>
-      <p:sp>
-        <p:nvSpPr>
-          <p:cNvPr id="46" name="文本框 45"/>
-          <p:cNvSpPr txBox="1"/>
-          <p:nvPr/>
-        </p:nvSpPr>
-        <p:spPr>
-          <a:xfrm>
-            <a:off x="2218822" y="1998071"/>
-            <a:ext cx="659155" cy="369332"/>
-          </a:xfrm>
-          <a:prstGeom prst="rect">
-            <a:avLst/>
-          </a:prstGeom>
-          <a:noFill/>
-        </p:spPr>
-        <p:txBody>
-          <a:bodyPr wrap="none" rtlCol="0">
-            <a:spAutoFit/>
-          </a:bodyPr>
-          <a:lstStyle/>
-          <a:p>
-            <a:r>
-              <a:rPr lang="en-US" altLang="zh-CN" dirty="0"/>
-              <a:t>3</a:t>
-            </a:r>
-            <a:r>
-              <a:rPr lang="zh-CN" altLang="en-US" dirty="0" smtClean="0"/>
-              <a:t>或</a:t>
-            </a:r>
-            <a:r>
-              <a:rPr lang="en-US" altLang="zh-CN" dirty="0"/>
-              <a:t>4</a:t>
-            </a:r>
-            <a:endParaRPr lang="zh-CN" altLang="en-US" dirty="0"/>
-          </a:p>
-        </p:txBody>
-      </p:sp>
-      <p:graphicFrame>
-        <p:nvGraphicFramePr>
-          <p:cNvPr id="47" name="表格 46"/>
-          <p:cNvGraphicFramePr>
-            <a:graphicFrameLocks noGrp="1"/>
-          </p:cNvGraphicFramePr>
-          <p:nvPr>
-            <p:extLst>
-              <p:ext uri="{D42A27DB-BD31-4B8C-83A1-F6EECF244321}">
-                <p14:modId xmlns:p14="http://schemas.microsoft.com/office/powerpoint/2010/main" val="4112918327"/>
-              </p:ext>
-            </p:extLst>
-          </p:nvPr>
-        </p:nvGraphicFramePr>
-        <p:xfrm>
-          <a:off x="6962090" y="765372"/>
-          <a:ext cx="4083062" cy="5824945"/>
-        </p:xfrm>
-        <a:graphic>
-          <a:graphicData uri="http://schemas.openxmlformats.org/drawingml/2006/table">
-            <a:tbl>
-              <a:tblPr firstRow="1" bandRow="1">
-                <a:tableStyleId>{5C22544A-7EE6-4342-B048-85BDC9FD1C3A}</a:tableStyleId>
-              </a:tblPr>
-              <a:tblGrid>
-                <a:gridCol w="2041531">
-                  <a:extLst>
-                    <a:ext uri="{9D8B030D-6E8A-4147-A177-3AD203B41FA5}">
-                      <a16:colId xmlns:a16="http://schemas.microsoft.com/office/drawing/2014/main" val="2104862403"/>
-                    </a:ext>
-                  </a:extLst>
-                </a:gridCol>
-                <a:gridCol w="2041531">
-                  <a:extLst>
-                    <a:ext uri="{9D8B030D-6E8A-4147-A177-3AD203B41FA5}">
-                      <a16:colId xmlns:a16="http://schemas.microsoft.com/office/drawing/2014/main" val="3631488225"/>
-                    </a:ext>
-                  </a:extLst>
-                </a:gridCol>
-              </a:tblGrid>
-              <a:tr h="406243">
-                <a:tc>
-                  <a:txBody>
-                    <a:bodyPr/>
-                    <a:lstStyle/>
-                    <a:p>
-                      <a:r>
-                        <a:rPr lang="zh-CN" altLang="en-US" dirty="0" smtClean="0"/>
-                        <a:t>总线</a:t>
-                      </a:r>
-                      <a:endParaRPr lang="zh-CN" altLang="en-US" dirty="0"/>
-                    </a:p>
-                  </a:txBody>
-                  <a:tcPr/>
-                </a:tc>
-                <a:tc>
-                  <a:txBody>
-                    <a:bodyPr/>
-                    <a:lstStyle/>
-                    <a:p>
-                      <a:r>
-                        <a:rPr lang="zh-CN" altLang="en-US" dirty="0" smtClean="0"/>
-                        <a:t>带宽</a:t>
-                      </a:r>
-                      <a:r>
-                        <a:rPr lang="en-US" altLang="zh-CN" dirty="0" err="1" smtClean="0"/>
-                        <a:t>GiB</a:t>
-                      </a:r>
-                      <a:r>
-                        <a:rPr lang="en-US" altLang="zh-CN" dirty="0" smtClean="0"/>
-                        <a:t>/s</a:t>
-                      </a:r>
-                      <a:endParaRPr lang="zh-CN" altLang="en-US" dirty="0"/>
-                    </a:p>
-                  </a:txBody>
-                  <a:tcPr/>
-                </a:tc>
-                <a:extLst>
-                  <a:ext uri="{0D108BD9-81ED-4DB2-BD59-A6C34878D82A}">
-                    <a16:rowId xmlns:a16="http://schemas.microsoft.com/office/drawing/2014/main" val="3322635084"/>
-                  </a:ext>
-                </a:extLst>
-              </a:tr>
-              <a:tr h="1031046">
-                <a:tc>
-                  <a:txBody>
-                    <a:bodyPr/>
-                    <a:lstStyle/>
-                    <a:p>
-                      <a:pPr marL="0" indent="0">
-                        <a:buNone/>
-                      </a:pPr>
-                      <a:r>
-                        <a:rPr lang="en-US" altLang="zh-CN" dirty="0" smtClean="0"/>
-                        <a:t>1  PCI-e 3.0</a:t>
-                      </a:r>
-                      <a:endParaRPr lang="en-US" altLang="zh-CN" dirty="0" smtClean="0"/>
-                    </a:p>
-                  </a:txBody>
-                  <a:tcPr/>
-                </a:tc>
-                <a:tc>
-                  <a:txBody>
-                    <a:bodyPr/>
-                    <a:lstStyle/>
-                    <a:p>
-                      <a:r>
-                        <a:rPr lang="en-US" altLang="zh-CN" dirty="0" smtClean="0"/>
-                        <a:t>12</a:t>
-                      </a:r>
-                      <a:endParaRPr lang="zh-CN" altLang="en-US" dirty="0"/>
-                    </a:p>
-                  </a:txBody>
-                  <a:tcPr/>
-                </a:tc>
-                <a:extLst>
-                  <a:ext uri="{0D108BD9-81ED-4DB2-BD59-A6C34878D82A}">
-                    <a16:rowId xmlns:a16="http://schemas.microsoft.com/office/drawing/2014/main" val="4110064030"/>
-                  </a:ext>
-                </a:extLst>
-              </a:tr>
-              <a:tr h="731276">
-                <a:tc>
-                  <a:txBody>
-                    <a:bodyPr/>
-                    <a:lstStyle/>
-                    <a:p>
-                      <a:pPr marL="0" indent="0">
-                        <a:buNone/>
-                      </a:pPr>
-                      <a:r>
-                        <a:rPr lang="en-US" altLang="zh-CN" dirty="0" smtClean="0"/>
-                        <a:t>2   </a:t>
-                      </a:r>
-                      <a:r>
-                        <a:rPr lang="en-US" altLang="zh-CN" dirty="0" err="1" smtClean="0"/>
-                        <a:t>NVLink</a:t>
-                      </a:r>
-                      <a:r>
-                        <a:rPr lang="en-US" altLang="zh-CN" dirty="0" smtClean="0"/>
-                        <a:t> 2.0</a:t>
-                      </a:r>
-                      <a:endParaRPr lang="en-US" altLang="zh-CN" dirty="0" smtClean="0"/>
-                    </a:p>
-                  </a:txBody>
-                  <a:tcPr/>
-                </a:tc>
-                <a:tc>
-                  <a:txBody>
-                    <a:bodyPr/>
-                    <a:lstStyle/>
-                    <a:p>
-                      <a:r>
-                        <a:rPr lang="en-US" altLang="zh-CN" dirty="0" smtClean="0"/>
-                        <a:t>63</a:t>
-                      </a:r>
-                      <a:endParaRPr lang="zh-CN" altLang="en-US" dirty="0"/>
-                    </a:p>
-                  </a:txBody>
-                  <a:tcPr/>
-                </a:tc>
-                <a:extLst>
-                  <a:ext uri="{0D108BD9-81ED-4DB2-BD59-A6C34878D82A}">
-                    <a16:rowId xmlns:a16="http://schemas.microsoft.com/office/drawing/2014/main" val="487215583"/>
-                  </a:ext>
-                </a:extLst>
-              </a:tr>
-              <a:tr h="731276">
-                <a:tc>
-                  <a:txBody>
-                    <a:bodyPr/>
-                    <a:lstStyle/>
-                    <a:p>
-                      <a:pPr marL="0" indent="0">
-                        <a:buNone/>
-                      </a:pPr>
-                      <a:r>
-                        <a:rPr lang="en-US" altLang="zh-CN" dirty="0" smtClean="0"/>
-                        <a:t>3  UPI</a:t>
-                      </a:r>
-                      <a:endParaRPr lang="en-US" altLang="zh-CN" dirty="0" smtClean="0"/>
-                    </a:p>
-                  </a:txBody>
-                  <a:tcPr/>
-                </a:tc>
-                <a:tc>
-                  <a:txBody>
-                    <a:bodyPr/>
-                    <a:lstStyle/>
-                    <a:p>
-                      <a:r>
-                        <a:rPr lang="en-US" altLang="zh-CN" dirty="0" smtClean="0"/>
-                        <a:t>32</a:t>
-                      </a:r>
-                      <a:endParaRPr lang="zh-CN" altLang="en-US" dirty="0"/>
-                    </a:p>
-                  </a:txBody>
-                  <a:tcPr/>
-                </a:tc>
-                <a:extLst>
-                  <a:ext uri="{0D108BD9-81ED-4DB2-BD59-A6C34878D82A}">
-                    <a16:rowId xmlns:a16="http://schemas.microsoft.com/office/drawing/2014/main" val="976593517"/>
-                  </a:ext>
-                </a:extLst>
-              </a:tr>
-              <a:tr h="731276">
-                <a:tc>
-                  <a:txBody>
-                    <a:bodyPr/>
-                    <a:lstStyle/>
-                    <a:p>
-                      <a:pPr marL="0" marR="0" indent="0" algn="l" defTabSz="914400" rtl="0" eaLnBrk="1" fontAlgn="auto" latinLnBrk="0" hangingPunct="1">
-                        <a:lnSpc>
-                          <a:spcPct val="100000"/>
-                        </a:lnSpc>
-                        <a:spcBef>
-                          <a:spcPts val="0"/>
-                        </a:spcBef>
-                        <a:spcAft>
-                          <a:spcPts val="0"/>
-                        </a:spcAft>
-                        <a:buClrTx/>
-                        <a:buSzTx/>
-                        <a:buFontTx/>
-                        <a:buNone/>
-                        <a:tabLst/>
-                        <a:defRPr/>
-                      </a:pPr>
-                      <a:r>
-                        <a:rPr lang="en-US" altLang="zh-CN" dirty="0" smtClean="0"/>
-                        <a:t>4 X-Bus</a:t>
-                      </a:r>
-                    </a:p>
-                    <a:p>
-                      <a:pPr marL="0" indent="0">
-                        <a:buNone/>
-                      </a:pPr>
-                      <a:endParaRPr lang="en-US" altLang="zh-CN" dirty="0" smtClean="0"/>
-                    </a:p>
-                  </a:txBody>
-                  <a:tcPr/>
-                </a:tc>
-                <a:tc>
-                  <a:txBody>
-                    <a:bodyPr/>
-                    <a:lstStyle/>
-                    <a:p>
-                      <a:r>
-                        <a:rPr lang="en-US" altLang="zh-CN" dirty="0" smtClean="0"/>
-                        <a:t>31</a:t>
-                      </a:r>
-                      <a:endParaRPr lang="zh-CN" altLang="en-US" dirty="0"/>
-                    </a:p>
-                  </a:txBody>
-                  <a:tcPr/>
-                </a:tc>
-                <a:extLst>
-                  <a:ext uri="{0D108BD9-81ED-4DB2-BD59-A6C34878D82A}">
-                    <a16:rowId xmlns:a16="http://schemas.microsoft.com/office/drawing/2014/main" val="1875395145"/>
-                  </a:ext>
-                </a:extLst>
-              </a:tr>
-              <a:tr h="731276">
-                <a:tc>
-                  <a:txBody>
-                    <a:bodyPr/>
-                    <a:lstStyle/>
-                    <a:p>
-                      <a:pPr marL="0" indent="0">
-                        <a:buNone/>
-                      </a:pPr>
-                      <a:r>
-                        <a:rPr lang="en-US" altLang="zh-CN" dirty="0" smtClean="0"/>
-                        <a:t>5</a:t>
-                      </a:r>
-                      <a:r>
-                        <a:rPr lang="en-US" altLang="zh-CN" sz="1800" b="0" i="0" kern="1200" dirty="0" smtClean="0">
-                          <a:solidFill>
-                            <a:schemeClr val="dk1"/>
-                          </a:solidFill>
-                          <a:effectLst/>
-                          <a:latin typeface="+mn-lt"/>
-                          <a:ea typeface="+mn-ea"/>
-                          <a:cs typeface="+mn-cs"/>
-                        </a:rPr>
-                        <a:t>Intel Xeon</a:t>
-                      </a:r>
-                      <a:endParaRPr lang="en-US" altLang="zh-CN" dirty="0" smtClean="0"/>
-                    </a:p>
-                  </a:txBody>
-                  <a:tcPr/>
-                </a:tc>
-                <a:tc>
-                  <a:txBody>
-                    <a:bodyPr/>
-                    <a:lstStyle/>
-                    <a:p>
-                      <a:r>
-                        <a:rPr lang="en-US" altLang="zh-CN" dirty="0" smtClean="0"/>
-                        <a:t>81</a:t>
-                      </a:r>
-                      <a:endParaRPr lang="zh-CN" altLang="en-US" dirty="0"/>
-                    </a:p>
-                  </a:txBody>
-                  <a:tcPr/>
-                </a:tc>
-                <a:extLst>
-                  <a:ext uri="{0D108BD9-81ED-4DB2-BD59-A6C34878D82A}">
-                    <a16:rowId xmlns:a16="http://schemas.microsoft.com/office/drawing/2014/main" val="2168560015"/>
-                  </a:ext>
-                </a:extLst>
-              </a:tr>
-              <a:tr h="731276">
-                <a:tc>
-                  <a:txBody>
-                    <a:bodyPr/>
-                    <a:lstStyle/>
-                    <a:p>
-                      <a:pPr marL="0" indent="0">
-                        <a:buNone/>
-                      </a:pPr>
-                      <a:r>
-                        <a:rPr lang="en-US" altLang="zh-CN" dirty="0" smtClean="0"/>
-                        <a:t>6</a:t>
-                      </a:r>
-                      <a:r>
-                        <a:rPr lang="en-US" altLang="zh-CN" sz="1800" b="0" i="0" kern="1200" dirty="0" smtClean="0">
-                          <a:solidFill>
-                            <a:schemeClr val="dk1"/>
-                          </a:solidFill>
-                          <a:effectLst/>
-                          <a:latin typeface="+mn-lt"/>
-                          <a:ea typeface="+mn-ea"/>
-                          <a:cs typeface="+mn-cs"/>
-                        </a:rPr>
-                        <a:t>IBM POWER9</a:t>
-                      </a:r>
-                      <a:endParaRPr lang="en-US" altLang="zh-CN" dirty="0" smtClean="0"/>
-                    </a:p>
-                  </a:txBody>
-                  <a:tcPr/>
-                </a:tc>
-                <a:tc>
-                  <a:txBody>
-                    <a:bodyPr/>
-                    <a:lstStyle/>
-                    <a:p>
-                      <a:r>
-                        <a:rPr lang="en-US" altLang="zh-CN" dirty="0" smtClean="0"/>
-                        <a:t>117</a:t>
-                      </a:r>
-                      <a:endParaRPr lang="zh-CN" altLang="en-US" dirty="0"/>
-                    </a:p>
-                  </a:txBody>
-                  <a:tcPr/>
-                </a:tc>
-                <a:extLst>
-                  <a:ext uri="{0D108BD9-81ED-4DB2-BD59-A6C34878D82A}">
-                    <a16:rowId xmlns:a16="http://schemas.microsoft.com/office/drawing/2014/main" val="2571877642"/>
-                  </a:ext>
-                </a:extLst>
-              </a:tr>
-              <a:tr h="731276">
-                <a:tc>
-                  <a:txBody>
-                    <a:bodyPr/>
-                    <a:lstStyle/>
-                    <a:p>
-                      <a:pPr marL="0" indent="0">
-                        <a:buNone/>
-                      </a:pPr>
-                      <a:r>
-                        <a:rPr lang="en-US" altLang="zh-CN" dirty="0" smtClean="0"/>
-                        <a:t>7</a:t>
-                      </a:r>
-                      <a:r>
-                        <a:rPr lang="en-US" altLang="zh-CN" sz="1800" b="0" i="0" kern="1200" dirty="0" smtClean="0">
-                          <a:solidFill>
-                            <a:schemeClr val="dk1"/>
-                          </a:solidFill>
-                          <a:effectLst/>
-                          <a:latin typeface="+mn-lt"/>
-                          <a:ea typeface="+mn-ea"/>
-                          <a:cs typeface="+mn-cs"/>
-                        </a:rPr>
-                        <a:t>Nvidia V100</a:t>
-                      </a:r>
-                      <a:endParaRPr lang="en-US" altLang="zh-CN" dirty="0" smtClean="0"/>
-                    </a:p>
-                  </a:txBody>
-                  <a:tcPr/>
-                </a:tc>
-                <a:tc>
-                  <a:txBody>
-                    <a:bodyPr/>
-                    <a:lstStyle/>
-                    <a:p>
-                      <a:r>
-                        <a:rPr lang="en-US" altLang="zh-CN" dirty="0" smtClean="0"/>
-                        <a:t>729</a:t>
-                      </a:r>
-                      <a:endParaRPr lang="zh-CN" altLang="en-US" dirty="0"/>
-                    </a:p>
-                  </a:txBody>
-                  <a:tcPr/>
-                </a:tc>
-                <a:extLst>
-                  <a:ext uri="{0D108BD9-81ED-4DB2-BD59-A6C34878D82A}">
-                    <a16:rowId xmlns:a16="http://schemas.microsoft.com/office/drawing/2014/main" val="2872256530"/>
-                  </a:ext>
-                </a:extLst>
-              </a:tr>
-            </a:tbl>
-          </a:graphicData>
-        </a:graphic>
-      </p:graphicFrame>
-      <p:sp>
-        <p:nvSpPr>
-          <p:cNvPr id="49" name="文本框 48"/>
-          <p:cNvSpPr txBox="1"/>
-          <p:nvPr/>
-        </p:nvSpPr>
-        <p:spPr>
-          <a:xfrm>
-            <a:off x="2057482" y="701177"/>
-            <a:ext cx="659155" cy="369332"/>
-          </a:xfrm>
-          <a:prstGeom prst="rect">
-            <a:avLst/>
-          </a:prstGeom>
-          <a:noFill/>
-        </p:spPr>
-        <p:txBody>
-          <a:bodyPr wrap="none" rtlCol="0">
-            <a:spAutoFit/>
-          </a:bodyPr>
-          <a:lstStyle/>
-          <a:p>
-            <a:r>
-              <a:rPr lang="en-US" altLang="zh-CN" dirty="0"/>
-              <a:t>5</a:t>
-            </a:r>
-            <a:r>
-              <a:rPr lang="zh-CN" altLang="en-US" dirty="0" smtClean="0"/>
-              <a:t>或</a:t>
-            </a:r>
-            <a:r>
-              <a:rPr lang="en-US" altLang="zh-CN" dirty="0"/>
-              <a:t>6</a:t>
-            </a:r>
-            <a:endParaRPr lang="zh-CN" altLang="en-US" dirty="0"/>
-          </a:p>
-        </p:txBody>
-      </p:sp>
-      <p:cxnSp>
-        <p:nvCxnSpPr>
-          <p:cNvPr id="50" name="直接箭头连接符 49"/>
-          <p:cNvCxnSpPr>
-            <a:endCxn id="4" idx="1"/>
-          </p:cNvCxnSpPr>
-          <p:nvPr/>
-        </p:nvCxnSpPr>
-        <p:spPr>
-          <a:xfrm>
-            <a:off x="1815766" y="1106937"/>
-            <a:ext cx="806113" cy="3441"/>
-          </a:xfrm>
-          <a:prstGeom prst="straightConnector1">
-            <a:avLst/>
-          </a:prstGeom>
-          <a:ln>
-            <a:prstDash val="dashDot"/>
-            <a:tailEnd type="triangle"/>
-          </a:ln>
-        </p:spPr>
-        <p:style>
-          <a:lnRef idx="1">
-            <a:schemeClr val="dk1"/>
-          </a:lnRef>
-          <a:fillRef idx="0">
-            <a:schemeClr val="dk1"/>
-          </a:fillRef>
-          <a:effectRef idx="0">
-            <a:schemeClr val="dk1"/>
-          </a:effectRef>
-          <a:fontRef idx="minor">
-            <a:schemeClr val="tx1"/>
-          </a:fontRef>
-        </p:style>
-      </p:cxnSp>
-      <p:cxnSp>
-        <p:nvCxnSpPr>
-          <p:cNvPr id="56" name="直接箭头连接符 55"/>
-          <p:cNvCxnSpPr>
-            <a:endCxn id="11" idx="3"/>
-          </p:cNvCxnSpPr>
-          <p:nvPr/>
-        </p:nvCxnSpPr>
-        <p:spPr>
-          <a:xfrm flipH="1">
-            <a:off x="4686914" y="1070509"/>
-            <a:ext cx="754703" cy="1745"/>
-          </a:xfrm>
-          <a:prstGeom prst="straightConnector1">
-            <a:avLst/>
-          </a:prstGeom>
-          <a:ln>
-            <a:prstDash val="dashDot"/>
-            <a:tailEnd type="triangle"/>
-          </a:ln>
-        </p:spPr>
-        <p:style>
-          <a:lnRef idx="1">
-            <a:schemeClr val="dk1"/>
-          </a:lnRef>
-          <a:fillRef idx="0">
-            <a:schemeClr val="dk1"/>
-          </a:fillRef>
-          <a:effectRef idx="0">
-            <a:schemeClr val="dk1"/>
-          </a:effectRef>
-          <a:fontRef idx="minor">
-            <a:schemeClr val="tx1"/>
-          </a:fontRef>
-        </p:style>
-      </p:cxnSp>
-      <p:sp>
-        <p:nvSpPr>
-          <p:cNvPr id="59" name="文本框 58"/>
-          <p:cNvSpPr txBox="1"/>
-          <p:nvPr/>
-        </p:nvSpPr>
-        <p:spPr>
-          <a:xfrm>
-            <a:off x="4678669" y="741802"/>
-            <a:ext cx="306494" cy="369332"/>
-          </a:xfrm>
-          <a:prstGeom prst="rect">
-            <a:avLst/>
-          </a:prstGeom>
-          <a:noFill/>
-        </p:spPr>
-        <p:txBody>
-          <a:bodyPr wrap="none" rtlCol="0">
-            <a:spAutoFit/>
-          </a:bodyPr>
-          <a:lstStyle/>
-          <a:p>
-            <a:r>
-              <a:rPr lang="en-US" altLang="zh-CN" dirty="0" smtClean="0"/>
-              <a:t>7</a:t>
-            </a:r>
-            <a:endParaRPr lang="zh-CN" altLang="en-US" dirty="0"/>
           </a:p>
         </p:txBody>
       </p:sp>
     </p:spTree>
     <p:extLst>
       <p:ext uri="{BB962C8B-B14F-4D97-AF65-F5344CB8AC3E}">
-        <p14:creationId xmlns:p14="http://schemas.microsoft.com/office/powerpoint/2010/main" val="2345161636"/>
+        <p14:creationId xmlns:p14="http://schemas.microsoft.com/office/powerpoint/2010/main" val="2405949957"/>
       </p:ext>
     </p:extLst>
   </p:cSld>
@@ -18333,109 +17004,6 @@
             <p:ph type="title"/>
           </p:nvPr>
         </p:nvSpPr>
-        <p:spPr/>
-        <p:txBody>
-          <a:bodyPr/>
-          <a:lstStyle/>
-          <a:p>
-            <a:r>
-              <a:rPr lang="zh-CN" altLang="en-US" dirty="0" smtClean="0"/>
-              <a:t>问老师的问题</a:t>
-            </a:r>
-            <a:endParaRPr lang="zh-CN" altLang="en-US" dirty="0"/>
-          </a:p>
-        </p:txBody>
-      </p:sp>
-      <p:sp>
-        <p:nvSpPr>
-          <p:cNvPr id="3" name="内容占位符 2"/>
-          <p:cNvSpPr>
-            <a:spLocks noGrp="1"/>
-          </p:cNvSpPr>
-          <p:nvPr>
-            <p:ph idx="1"/>
-          </p:nvPr>
-        </p:nvSpPr>
-        <p:spPr/>
-        <p:txBody>
-          <a:bodyPr>
-            <a:normAutofit/>
-          </a:bodyPr>
-          <a:lstStyle/>
-          <a:p>
-            <a:pPr marL="0" lvl="0" indent="0">
-              <a:buNone/>
-            </a:pPr>
-            <a:r>
-              <a:rPr lang="zh-CN" altLang="en-US" dirty="0" smtClean="0"/>
-              <a:t>许多问题已经问了</a:t>
-            </a:r>
-            <a:r>
-              <a:rPr lang="en-US" altLang="zh-CN" dirty="0" smtClean="0"/>
-              <a:t> </a:t>
-            </a:r>
-            <a:r>
-              <a:rPr lang="en-US" altLang="zh-CN" dirty="0" err="1"/>
-              <a:t>Z</a:t>
-            </a:r>
-            <a:r>
-              <a:rPr lang="en-US" altLang="zh-CN" dirty="0" err="1" smtClean="0"/>
-              <a:t>iyue</a:t>
-            </a:r>
-            <a:r>
-              <a:rPr lang="en-US" altLang="zh-CN" dirty="0" smtClean="0"/>
-              <a:t> Luo</a:t>
-            </a:r>
-          </a:p>
-        </p:txBody>
-      </p:sp>
-    </p:spTree>
-    <p:extLst>
-      <p:ext uri="{BB962C8B-B14F-4D97-AF65-F5344CB8AC3E}">
-        <p14:creationId xmlns:p14="http://schemas.microsoft.com/office/powerpoint/2010/main" val="2405949957"/>
-      </p:ext>
-    </p:extLst>
-  </p:cSld>
-  <p:clrMapOvr>
-    <a:masterClrMapping/>
-  </p:clrMapOvr>
-  <p:timing>
-    <p:tnLst>
-      <p:par>
-        <p:cTn id="1" dur="indefinite" restart="never" nodeType="tmRoot"/>
-      </p:par>
-    </p:tnLst>
-  </p:timing>
-</p:sld>
-</file>
-
-<file path=ppt/slides/slide12.xml><?xml version="1.0" encoding="utf-8"?>
-<p:sld xmlns:a="http://schemas.openxmlformats.org/drawingml/2006/main" xmlns:r="http://schemas.openxmlformats.org/officeDocument/2006/relationships" xmlns:p="http://schemas.openxmlformats.org/presentationml/2006/main">
-  <p:cSld>
-    <p:spTree>
-      <p:nvGrpSpPr>
-        <p:cNvPr id="1" name=""/>
-        <p:cNvGrpSpPr/>
-        <p:nvPr/>
-      </p:nvGrpSpPr>
-      <p:grpSpPr>
-        <a:xfrm>
-          <a:off x="0" y="0"/>
-          <a:ext cx="0" cy="0"/>
-          <a:chOff x="0" y="0"/>
-          <a:chExt cx="0" cy="0"/>
-        </a:xfrm>
-      </p:grpSpPr>
-      <p:sp>
-        <p:nvSpPr>
-          <p:cNvPr id="2" name="标题 1"/>
-          <p:cNvSpPr>
-            <a:spLocks noGrp="1"/>
-          </p:cNvSpPr>
-          <p:nvPr>
-            <p:ph type="title"/>
-          </p:nvPr>
-        </p:nvSpPr>
         <p:spPr>
           <a:xfrm>
             <a:off x="838200" y="299137"/>
@@ -18463,7 +17031,7 @@
           <p:nvPr>
             <p:extLst>
               <p:ext uri="{D42A27DB-BD31-4B8C-83A1-F6EECF244321}">
-                <p14:modId xmlns:p14="http://schemas.microsoft.com/office/powerpoint/2010/main" val="2215933290"/>
+                <p14:modId xmlns:p14="http://schemas.microsoft.com/office/powerpoint/2010/main" val="2522570103"/>
               </p:ext>
             </p:extLst>
           </p:nvPr>
@@ -18666,6 +17234,10 @@
                       <a:r>
                         <a:rPr lang="en-US" altLang="zh-CN" dirty="0" err="1" smtClean="0"/>
                         <a:t>EuroSys</a:t>
+                      </a:r>
+                      <a:r>
+                        <a:rPr lang="zh-CN" altLang="en-US" dirty="0" smtClean="0"/>
+                        <a:t>会议</a:t>
                       </a:r>
                       <a:endParaRPr lang="zh-CN" altLang="en-US" dirty="0"/>
                     </a:p>
@@ -18967,7 +17539,6 @@
               <a:rPr lang="en-US" altLang="zh-CN" dirty="0" smtClean="0"/>
               <a:t>reward. </a:t>
             </a:r>
-            <a:endParaRPr lang="en-US" altLang="zh-CN" dirty="0" smtClean="0"/>
           </a:p>
           <a:p>
             <a:r>
@@ -18975,12 +17546,20 @@
               <a:t>对</a:t>
             </a:r>
             <a:r>
-              <a:rPr lang="en-US" altLang="zh-CN" dirty="0" err="1" smtClean="0"/>
-              <a:t>placment</a:t>
+              <a:rPr lang="en-US" altLang="zh-CN" dirty="0" smtClean="0"/>
+              <a:t>placement</a:t>
             </a:r>
             <a:r>
               <a:rPr lang="zh-CN" altLang="en-US" dirty="0" smtClean="0"/>
-              <a:t>的影响估计</a:t>
+              <a:t>的</a:t>
+            </a:r>
+            <a:r>
+              <a:rPr lang="zh-CN" altLang="en-US" dirty="0" smtClean="0"/>
+              <a:t> 通讯时间</a:t>
+            </a:r>
+            <a:r>
+              <a:rPr lang="zh-CN" altLang="en-US" dirty="0" smtClean="0"/>
+              <a:t>估计</a:t>
             </a:r>
             <a:endParaRPr lang="en-US" altLang="zh-CN" dirty="0" smtClean="0"/>
           </a:p>
@@ -21310,7 +19889,7 @@
           <p:nvPr>
             <p:extLst>
               <p:ext uri="{D42A27DB-BD31-4B8C-83A1-F6EECF244321}">
-                <p14:modId xmlns:p14="http://schemas.microsoft.com/office/powerpoint/2010/main" val="3072695297"/>
+                <p14:modId xmlns:p14="http://schemas.microsoft.com/office/powerpoint/2010/main" val="2844719419"/>
               </p:ext>
             </p:extLst>
           </p:nvPr>
@@ -21457,7 +20036,11 @@
                     <a:p>
                       <a:r>
                         <a:rPr lang="zh-CN" altLang="en-US" dirty="0" smtClean="0"/>
-                        <a:t>梯度噪声规模</a:t>
+                        <a:t>梯度</a:t>
+                      </a:r>
+                      <a:r>
+                        <a:rPr lang="zh-CN" altLang="en-US" dirty="0" smtClean="0"/>
+                        <a:t>噪声</a:t>
                       </a:r>
                       <a:r>
                         <a:rPr lang="en-US" altLang="zh-CN" dirty="0" smtClean="0"/>
@@ -21490,12 +20073,12 @@
                         <a:t>a, </a:t>
                       </a:r>
                       <a:r>
-                        <a:rPr lang="en-US" altLang="zh-CN" dirty="0" err="1" smtClean="0"/>
-                        <a:t>batach</a:t>
-                      </a:r>
-                      <a:r>
                         <a:rPr lang="en-US" altLang="zh-CN" dirty="0" smtClean="0"/>
-                        <a:t> size m , </a:t>
+                        <a:t>batch </a:t>
+                      </a:r>
+                      <a:r>
+                        <a:rPr lang="en-US" altLang="zh-CN" dirty="0" smtClean="0"/>
+                        <a:t>size m , </a:t>
                       </a:r>
                       <a:r>
                         <a:rPr lang="zh-CN" altLang="en-US" dirty="0" smtClean="0"/>
@@ -21549,12 +20132,13 @@
                     <a:p>
                       <a:r>
                         <a:rPr lang="zh-CN" altLang="en-US" dirty="0" smtClean="0"/>
-                        <a:t>拟合的参数</a:t>
-                      </a:r>
-                      <a:r>
-                        <a:rPr lang="en-US" altLang="zh-CN" dirty="0" smtClean="0"/>
-                        <a:t>,</a:t>
-                      </a:r>
+                        <a:t>拟合的</a:t>
+                      </a:r>
+                      <a:r>
+                        <a:rPr lang="zh-CN" altLang="en-US" dirty="0" smtClean="0"/>
+                        <a:t>参数</a:t>
+                      </a:r>
+                      <a:endParaRPr lang="en-US" altLang="zh-CN" dirty="0" smtClean="0"/>
                     </a:p>
                   </a:txBody>
                   <a:tcPr/>
@@ -21641,6 +20225,10 @@
                     <a:bodyPr/>
                     <a:lstStyle/>
                     <a:p>
+                      <a:r>
+                        <a:rPr lang="zh-CN" altLang="en-US" dirty="0" smtClean="0"/>
+                        <a:t>作业分配</a:t>
+                      </a:r>
                       <a:endParaRPr lang="zh-CN" altLang="en-US" dirty="0"/>
                     </a:p>
                   </a:txBody>
@@ -21724,7 +20312,6 @@
               <a:rPr lang="zh-CN" altLang="en-US" dirty="0"/>
               <a:t>设计</a:t>
             </a:r>
-            <a:endParaRPr lang="zh-CN" altLang="en-US" dirty="0"/>
           </a:p>
         </p:txBody>
       </p:sp>
@@ -21760,7 +20347,7 @@
       </p:grpSpPr>
       <p:sp>
         <p:nvSpPr>
-          <p:cNvPr id="3" name="标题 1"/>
+          <p:cNvPr id="2" name="标题 1"/>
           <p:cNvSpPr>
             <a:spLocks noGrp="1"/>
           </p:cNvSpPr>
@@ -21768,19 +20355,18 @@
             <p:ph type="title"/>
           </p:nvPr>
         </p:nvSpPr>
-        <p:spPr>
-          <a:xfrm>
-            <a:off x="838200" y="365125"/>
-            <a:ext cx="10515600" cy="1325563"/>
-          </a:xfrm>
-        </p:spPr>
+        <p:spPr/>
         <p:txBody>
           <a:bodyPr/>
           <a:lstStyle/>
           <a:p>
             <a:r>
+              <a:rPr lang="en-US" altLang="zh-CN" dirty="0" smtClean="0"/>
+              <a:t>Device </a:t>
+            </a:r>
+            <a:r>
               <a:rPr lang="zh-CN" altLang="en-US" dirty="0" smtClean="0"/>
-              <a:t>互联的影响</a:t>
+              <a:t>通讯速度估计</a:t>
             </a:r>
             <a:endParaRPr lang="zh-CN" altLang="en-US" dirty="0"/>
           </a:p>
@@ -21788,7 +20374,7 @@
       </p:sp>
       <p:sp>
         <p:nvSpPr>
-          <p:cNvPr id="5" name="内容占位符 2"/>
+          <p:cNvPr id="3" name="内容占位符 2"/>
           <p:cNvSpPr>
             <a:spLocks noGrp="1"/>
           </p:cNvSpPr>
@@ -21798,8 +20384,8 @@
         </p:nvSpPr>
         <p:spPr>
           <a:xfrm>
-            <a:off x="838200" y="1825625"/>
-            <a:ext cx="10515600" cy="3289300"/>
+            <a:off x="838200" y="1838504"/>
+            <a:ext cx="10515600" cy="4351338"/>
           </a:xfrm>
         </p:spPr>
         <p:txBody>
@@ -21811,6 +20397,80 @@
             <a:pPr marL="0" lvl="0" indent="0">
               <a:buNone/>
             </a:pPr>
+            <a:r>
+              <a:rPr lang="zh-CN" altLang="en-US" dirty="0" smtClean="0"/>
+              <a:t>我根据各个模型的参数个数</a:t>
+            </a:r>
+            <a:r>
+              <a:rPr lang="en-US" altLang="zh-CN" dirty="0" smtClean="0"/>
+              <a:t>, </a:t>
+            </a:r>
+            <a:r>
+              <a:rPr lang="zh-CN" altLang="en-US" dirty="0" smtClean="0"/>
+              <a:t>计算梯度的大小</a:t>
+            </a:r>
+            <a:r>
+              <a:rPr lang="en-US" altLang="zh-CN" dirty="0" smtClean="0"/>
+              <a:t>.</a:t>
+            </a:r>
+          </a:p>
+          <a:p>
+            <a:pPr marL="0" lvl="0" indent="0">
+              <a:buNone/>
+            </a:pPr>
+            <a:r>
+              <a:rPr lang="zh-CN" altLang="en-US" dirty="0" smtClean="0"/>
+              <a:t>然后根据各个总线速度</a:t>
+            </a:r>
+            <a:r>
+              <a:rPr lang="en-US" altLang="zh-CN" dirty="0" smtClean="0"/>
+              <a:t>,  </a:t>
+            </a:r>
+            <a:r>
+              <a:rPr lang="zh-CN" altLang="en-US" dirty="0" smtClean="0"/>
+              <a:t>计算</a:t>
+            </a:r>
+            <a:r>
+              <a:rPr lang="en-US" altLang="zh-CN" dirty="0" smtClean="0"/>
+              <a:t>PS </a:t>
+            </a:r>
+            <a:r>
+              <a:rPr lang="zh-CN" altLang="en-US" dirty="0" smtClean="0"/>
+              <a:t>和 </a:t>
+            </a:r>
+            <a:r>
+              <a:rPr lang="en-US" altLang="zh-CN" dirty="0" smtClean="0"/>
+              <a:t>all reduce </a:t>
+            </a:r>
+            <a:r>
+              <a:rPr lang="zh-CN" altLang="en-US" dirty="0" smtClean="0"/>
+              <a:t>两种</a:t>
+            </a:r>
+            <a:r>
+              <a:rPr lang="en-US" altLang="zh-CN" dirty="0" smtClean="0"/>
+              <a:t>architecture  </a:t>
+            </a:r>
+            <a:r>
+              <a:rPr lang="zh-CN" altLang="en-US" dirty="0" smtClean="0"/>
+              <a:t>的通讯时间</a:t>
+            </a:r>
+            <a:r>
+              <a:rPr lang="en-US" altLang="zh-CN" dirty="0" smtClean="0"/>
+              <a:t>.</a:t>
+            </a:r>
+          </a:p>
+          <a:p>
+            <a:pPr marL="0" lvl="0" indent="0">
+              <a:buNone/>
+            </a:pPr>
+            <a:r>
+              <a:rPr lang="zh-CN" altLang="en-US" dirty="0" smtClean="0"/>
+              <a:t>下面是一些总线的传输速度</a:t>
+            </a:r>
+            <a:r>
+              <a:rPr lang="en-US" altLang="zh-CN" dirty="0" smtClean="0"/>
+              <a:t>.</a:t>
+            </a:r>
             <a:endParaRPr lang="en-US" altLang="zh-CN" dirty="0" smtClean="0"/>
           </a:p>
         </p:txBody>
@@ -21818,7 +20478,7 @@
     </p:spTree>
     <p:extLst>
       <p:ext uri="{BB962C8B-B14F-4D97-AF65-F5344CB8AC3E}">
-        <p14:creationId xmlns:p14="http://schemas.microsoft.com/office/powerpoint/2010/main" val="2382349123"/>
+        <p14:creationId xmlns:p14="http://schemas.microsoft.com/office/powerpoint/2010/main" val="829079174"/>
       </p:ext>
     </p:extLst>
   </p:cSld>
@@ -21854,27 +20514,1306 @@
       </p:grpSpPr>
       <p:sp>
         <p:nvSpPr>
-          <p:cNvPr id="3" name="标题 1"/>
-          <p:cNvSpPr>
-            <a:spLocks noGrp="1"/>
-          </p:cNvSpPr>
-          <p:nvPr>
-            <p:ph type="title"/>
-          </p:nvPr>
+          <p:cNvPr id="4" name="矩形 3"/>
+          <p:cNvSpPr/>
+          <p:nvPr/>
         </p:nvSpPr>
         <p:spPr>
           <a:xfrm>
-            <a:off x="838200" y="365125"/>
-            <a:ext cx="10515600" cy="1325563"/>
+            <a:off x="2621879" y="805794"/>
+            <a:ext cx="803563" cy="609167"/>
           </a:xfrm>
+          <a:prstGeom prst="rect">
+            <a:avLst/>
+          </a:prstGeom>
+        </p:spPr>
+        <p:style>
+          <a:lnRef idx="2">
+            <a:schemeClr val="accent1">
+              <a:shade val="50000"/>
+            </a:schemeClr>
+          </a:lnRef>
+          <a:fillRef idx="1">
+            <a:schemeClr val="accent1"/>
+          </a:fillRef>
+          <a:effectRef idx="0">
+            <a:schemeClr val="accent1"/>
+          </a:effectRef>
+          <a:fontRef idx="minor">
+            <a:schemeClr val="lt1"/>
+          </a:fontRef>
+        </p:style>
+        <p:txBody>
+          <a:bodyPr rtlCol="0" anchor="ctr"/>
+          <a:lstStyle/>
+          <a:p>
+            <a:pPr algn="ctr"/>
+            <a:r>
+              <a:rPr lang="en-US" altLang="zh-CN" dirty="0" smtClean="0"/>
+              <a:t>CPU0</a:t>
+            </a:r>
+            <a:endParaRPr lang="zh-CN" altLang="en-US" dirty="0"/>
+          </a:p>
+        </p:txBody>
+      </p:sp>
+      <p:sp>
+        <p:nvSpPr>
+          <p:cNvPr id="6" name="矩形 5"/>
+          <p:cNvSpPr/>
+          <p:nvPr/>
+        </p:nvSpPr>
+        <p:spPr>
+          <a:xfrm>
+            <a:off x="1328949" y="851575"/>
+            <a:ext cx="803563" cy="536170"/>
+          </a:xfrm>
+          <a:prstGeom prst="rect">
+            <a:avLst/>
+          </a:prstGeom>
+        </p:spPr>
+        <p:style>
+          <a:lnRef idx="2">
+            <a:schemeClr val="accent1">
+              <a:shade val="50000"/>
+            </a:schemeClr>
+          </a:lnRef>
+          <a:fillRef idx="1">
+            <a:schemeClr val="accent1"/>
+          </a:fillRef>
+          <a:effectRef idx="0">
+            <a:schemeClr val="accent1"/>
+          </a:effectRef>
+          <a:fontRef idx="minor">
+            <a:schemeClr val="lt1"/>
+          </a:fontRef>
+        </p:style>
+        <p:txBody>
+          <a:bodyPr rtlCol="0" anchor="ctr"/>
+          <a:lstStyle/>
+          <a:p>
+            <a:pPr algn="ctr"/>
+            <a:endParaRPr lang="zh-CN" altLang="en-US" dirty="0"/>
+          </a:p>
+        </p:txBody>
+      </p:sp>
+      <p:sp>
+        <p:nvSpPr>
+          <p:cNvPr id="7" name="文本框 6"/>
+          <p:cNvSpPr txBox="1"/>
+          <p:nvPr/>
+        </p:nvSpPr>
+        <p:spPr>
+          <a:xfrm>
+            <a:off x="1051957" y="528893"/>
+            <a:ext cx="1183337" cy="369332"/>
+          </a:xfrm>
+          <a:prstGeom prst="rect">
+            <a:avLst/>
+          </a:prstGeom>
+          <a:noFill/>
         </p:spPr>
         <p:txBody>
-          <a:bodyPr/>
+          <a:bodyPr wrap="none" rtlCol="0">
+            <a:spAutoFit/>
+          </a:bodyPr>
           <a:lstStyle/>
           <a:p>
+            <a:r>
+              <a:rPr lang="en-US" altLang="zh-CN" dirty="0" smtClean="0"/>
+              <a:t>CPU Mem</a:t>
+            </a:r>
+            <a:endParaRPr lang="zh-CN" altLang="en-US" dirty="0"/>
+          </a:p>
+        </p:txBody>
+      </p:sp>
+      <p:sp>
+        <p:nvSpPr>
+          <p:cNvPr id="8" name="矩形 7"/>
+          <p:cNvSpPr/>
+          <p:nvPr/>
+        </p:nvSpPr>
+        <p:spPr>
+          <a:xfrm>
+            <a:off x="2599777" y="2756440"/>
+            <a:ext cx="803563" cy="609167"/>
+          </a:xfrm>
+          <a:prstGeom prst="rect">
+            <a:avLst/>
+          </a:prstGeom>
+        </p:spPr>
+        <p:style>
+          <a:lnRef idx="2">
+            <a:schemeClr val="accent1">
+              <a:shade val="50000"/>
+            </a:schemeClr>
+          </a:lnRef>
+          <a:fillRef idx="1">
+            <a:schemeClr val="accent1"/>
+          </a:fillRef>
+          <a:effectRef idx="0">
+            <a:schemeClr val="accent1"/>
+          </a:effectRef>
+          <a:fontRef idx="minor">
+            <a:schemeClr val="lt1"/>
+          </a:fontRef>
+        </p:style>
+        <p:txBody>
+          <a:bodyPr rtlCol="0" anchor="ctr"/>
+          <a:lstStyle/>
+          <a:p>
+            <a:pPr algn="ctr"/>
+            <a:r>
+              <a:rPr lang="en-US" altLang="zh-CN" dirty="0" smtClean="0"/>
+              <a:t>CPU1</a:t>
+            </a:r>
+            <a:endParaRPr lang="zh-CN" altLang="en-US" dirty="0"/>
+          </a:p>
+        </p:txBody>
+      </p:sp>
+      <p:sp>
+        <p:nvSpPr>
+          <p:cNvPr id="9" name="矩形 8"/>
+          <p:cNvSpPr/>
+          <p:nvPr/>
+        </p:nvSpPr>
+        <p:spPr>
+          <a:xfrm>
+            <a:off x="1597872" y="2817272"/>
+            <a:ext cx="803563" cy="536170"/>
+          </a:xfrm>
+          <a:prstGeom prst="rect">
+            <a:avLst/>
+          </a:prstGeom>
+        </p:spPr>
+        <p:style>
+          <a:lnRef idx="2">
+            <a:schemeClr val="accent1">
+              <a:shade val="50000"/>
+            </a:schemeClr>
+          </a:lnRef>
+          <a:fillRef idx="1">
+            <a:schemeClr val="accent1"/>
+          </a:fillRef>
+          <a:effectRef idx="0">
+            <a:schemeClr val="accent1"/>
+          </a:effectRef>
+          <a:fontRef idx="minor">
+            <a:schemeClr val="lt1"/>
+          </a:fontRef>
+        </p:style>
+        <p:txBody>
+          <a:bodyPr rtlCol="0" anchor="ctr"/>
+          <a:lstStyle/>
+          <a:p>
+            <a:pPr algn="ctr"/>
+            <a:endParaRPr lang="zh-CN" altLang="en-US" dirty="0"/>
+          </a:p>
+        </p:txBody>
+      </p:sp>
+      <p:sp>
+        <p:nvSpPr>
+          <p:cNvPr id="10" name="文本框 9"/>
+          <p:cNvSpPr txBox="1"/>
+          <p:nvPr/>
+        </p:nvSpPr>
+        <p:spPr>
+          <a:xfrm>
+            <a:off x="1223881" y="2460104"/>
+            <a:ext cx="1183337" cy="369332"/>
+          </a:xfrm>
+          <a:prstGeom prst="rect">
+            <a:avLst/>
+          </a:prstGeom>
+          <a:noFill/>
+        </p:spPr>
+        <p:txBody>
+          <a:bodyPr wrap="none" rtlCol="0">
+            <a:spAutoFit/>
+          </a:bodyPr>
+          <a:lstStyle/>
+          <a:p>
+            <a:r>
+              <a:rPr lang="en-US" altLang="zh-CN" dirty="0" smtClean="0"/>
+              <a:t>CPU Mem</a:t>
+            </a:r>
+            <a:endParaRPr lang="zh-CN" altLang="en-US" dirty="0"/>
+          </a:p>
+        </p:txBody>
+      </p:sp>
+      <p:sp>
+        <p:nvSpPr>
+          <p:cNvPr id="11" name="矩形 10"/>
+          <p:cNvSpPr/>
+          <p:nvPr/>
+        </p:nvSpPr>
+        <p:spPr>
+          <a:xfrm>
+            <a:off x="3883351" y="767670"/>
+            <a:ext cx="803563" cy="609167"/>
+          </a:xfrm>
+          <a:prstGeom prst="rect">
+            <a:avLst/>
+          </a:prstGeom>
+        </p:spPr>
+        <p:style>
+          <a:lnRef idx="2">
+            <a:schemeClr val="accent1">
+              <a:shade val="50000"/>
+            </a:schemeClr>
+          </a:lnRef>
+          <a:fillRef idx="1">
+            <a:schemeClr val="accent1"/>
+          </a:fillRef>
+          <a:effectRef idx="0">
+            <a:schemeClr val="accent1"/>
+          </a:effectRef>
+          <a:fontRef idx="minor">
+            <a:schemeClr val="lt1"/>
+          </a:fontRef>
+        </p:style>
+        <p:txBody>
+          <a:bodyPr rtlCol="0" anchor="ctr"/>
+          <a:lstStyle/>
+          <a:p>
+            <a:pPr algn="ctr"/>
+            <a:r>
+              <a:rPr lang="en-US" altLang="zh-CN" dirty="0" smtClean="0"/>
+              <a:t>GPU0</a:t>
+            </a:r>
+            <a:endParaRPr lang="zh-CN" altLang="en-US" dirty="0"/>
+          </a:p>
+        </p:txBody>
+      </p:sp>
+      <p:sp>
+        <p:nvSpPr>
+          <p:cNvPr id="12" name="矩形 11"/>
+          <p:cNvSpPr/>
+          <p:nvPr/>
+        </p:nvSpPr>
+        <p:spPr>
+          <a:xfrm>
+            <a:off x="5002206" y="767670"/>
+            <a:ext cx="803563" cy="609167"/>
+          </a:xfrm>
+          <a:prstGeom prst="rect">
+            <a:avLst/>
+          </a:prstGeom>
+        </p:spPr>
+        <p:style>
+          <a:lnRef idx="2">
+            <a:schemeClr val="accent1">
+              <a:shade val="50000"/>
+            </a:schemeClr>
+          </a:lnRef>
+          <a:fillRef idx="1">
+            <a:schemeClr val="accent1"/>
+          </a:fillRef>
+          <a:effectRef idx="0">
+            <a:schemeClr val="accent1"/>
+          </a:effectRef>
+          <a:fontRef idx="minor">
+            <a:schemeClr val="lt1"/>
+          </a:fontRef>
+        </p:style>
+        <p:txBody>
+          <a:bodyPr rtlCol="0" anchor="ctr"/>
+          <a:lstStyle/>
+          <a:p>
+            <a:pPr algn="ctr"/>
+            <a:endParaRPr lang="zh-CN" altLang="en-US" dirty="0"/>
+          </a:p>
+        </p:txBody>
+      </p:sp>
+      <p:sp>
+        <p:nvSpPr>
+          <p:cNvPr id="13" name="文本框 12"/>
+          <p:cNvSpPr txBox="1"/>
+          <p:nvPr/>
+        </p:nvSpPr>
+        <p:spPr>
+          <a:xfrm>
+            <a:off x="4805908" y="398338"/>
+            <a:ext cx="1196161" cy="369332"/>
+          </a:xfrm>
+          <a:prstGeom prst="rect">
+            <a:avLst/>
+          </a:prstGeom>
+          <a:noFill/>
+        </p:spPr>
+        <p:txBody>
+          <a:bodyPr wrap="none" rtlCol="0">
+            <a:spAutoFit/>
+          </a:bodyPr>
+          <a:lstStyle/>
+          <a:p>
+            <a:r>
+              <a:rPr lang="en-US" altLang="zh-CN" dirty="0"/>
+              <a:t>G</a:t>
+            </a:r>
+            <a:r>
+              <a:rPr lang="en-US" altLang="zh-CN" dirty="0" smtClean="0"/>
+              <a:t>PU Mem</a:t>
+            </a:r>
+            <a:endParaRPr lang="zh-CN" altLang="en-US" dirty="0"/>
+          </a:p>
+        </p:txBody>
+      </p:sp>
+      <p:sp>
+        <p:nvSpPr>
+          <p:cNvPr id="14" name="矩形 13"/>
+          <p:cNvSpPr/>
+          <p:nvPr/>
+        </p:nvSpPr>
+        <p:spPr>
+          <a:xfrm>
+            <a:off x="3883351" y="2747141"/>
+            <a:ext cx="803563" cy="609167"/>
+          </a:xfrm>
+          <a:prstGeom prst="rect">
+            <a:avLst/>
+          </a:prstGeom>
+        </p:spPr>
+        <p:style>
+          <a:lnRef idx="2">
+            <a:schemeClr val="accent1">
+              <a:shade val="50000"/>
+            </a:schemeClr>
+          </a:lnRef>
+          <a:fillRef idx="1">
+            <a:schemeClr val="accent1"/>
+          </a:fillRef>
+          <a:effectRef idx="0">
+            <a:schemeClr val="accent1"/>
+          </a:effectRef>
+          <a:fontRef idx="minor">
+            <a:schemeClr val="lt1"/>
+          </a:fontRef>
+        </p:style>
+        <p:txBody>
+          <a:bodyPr rtlCol="0" anchor="ctr"/>
+          <a:lstStyle/>
+          <a:p>
+            <a:pPr algn="ctr"/>
+            <a:r>
+              <a:rPr lang="en-US" altLang="zh-CN" dirty="0" smtClean="0"/>
+              <a:t>GPU1</a:t>
+            </a:r>
+            <a:endParaRPr lang="zh-CN" altLang="en-US" dirty="0"/>
+          </a:p>
+        </p:txBody>
+      </p:sp>
+      <p:cxnSp>
+        <p:nvCxnSpPr>
+          <p:cNvPr id="18" name="直接箭头连接符 17"/>
+          <p:cNvCxnSpPr>
+            <a:stCxn id="8" idx="3"/>
+            <a:endCxn id="14" idx="1"/>
+          </p:cNvCxnSpPr>
+          <p:nvPr/>
+        </p:nvCxnSpPr>
+        <p:spPr>
+          <a:xfrm flipV="1">
+            <a:off x="3403340" y="3051725"/>
+            <a:ext cx="480011" cy="9299"/>
+          </a:xfrm>
+          <a:prstGeom prst="straightConnector1">
+            <a:avLst/>
+          </a:prstGeom>
+          <a:ln>
+            <a:headEnd type="triangle"/>
+            <a:tailEnd type="triangle"/>
+          </a:ln>
+        </p:spPr>
+        <p:style>
+          <a:lnRef idx="1">
+            <a:schemeClr val="accent1"/>
+          </a:lnRef>
+          <a:fillRef idx="0">
+            <a:schemeClr val="accent1"/>
+          </a:fillRef>
+          <a:effectRef idx="0">
+            <a:schemeClr val="accent1"/>
+          </a:effectRef>
+          <a:fontRef idx="minor">
+            <a:schemeClr val="tx1"/>
+          </a:fontRef>
+        </p:style>
+      </p:cxnSp>
+      <p:cxnSp>
+        <p:nvCxnSpPr>
+          <p:cNvPr id="24" name="直接箭头连接符 23"/>
+          <p:cNvCxnSpPr/>
+          <p:nvPr/>
+        </p:nvCxnSpPr>
+        <p:spPr>
+          <a:xfrm>
+            <a:off x="1915080" y="1257383"/>
+            <a:ext cx="2180167" cy="5541"/>
+          </a:xfrm>
+          <a:prstGeom prst="straightConnector1">
+            <a:avLst/>
+          </a:prstGeom>
+          <a:ln>
+            <a:prstDash val="dashDot"/>
+            <a:tailEnd type="triangle"/>
+          </a:ln>
+        </p:spPr>
+        <p:style>
+          <a:lnRef idx="1">
+            <a:schemeClr val="dk1"/>
+          </a:lnRef>
+          <a:fillRef idx="0">
+            <a:schemeClr val="dk1"/>
+          </a:fillRef>
+          <a:effectRef idx="0">
+            <a:schemeClr val="dk1"/>
+          </a:effectRef>
+          <a:fontRef idx="minor">
+            <a:schemeClr val="tx1"/>
+          </a:fontRef>
+        </p:style>
+      </p:cxnSp>
+      <p:sp>
+        <p:nvSpPr>
+          <p:cNvPr id="31" name="文本框 30"/>
+          <p:cNvSpPr txBox="1"/>
+          <p:nvPr/>
+        </p:nvSpPr>
+        <p:spPr>
+          <a:xfrm>
+            <a:off x="3576807" y="1236887"/>
+            <a:ext cx="659155" cy="369332"/>
+          </a:xfrm>
+          <a:prstGeom prst="rect">
+            <a:avLst/>
+          </a:prstGeom>
+          <a:noFill/>
+        </p:spPr>
+        <p:txBody>
+          <a:bodyPr wrap="none" rtlCol="0">
+            <a:spAutoFit/>
+          </a:bodyPr>
+          <a:lstStyle/>
+          <a:p>
+            <a:r>
+              <a:rPr lang="en-US" altLang="zh-CN" dirty="0" smtClean="0"/>
+              <a:t>1</a:t>
+            </a:r>
             <a:r>
               <a:rPr lang="zh-CN" altLang="en-US" dirty="0" smtClean="0"/>
-              <a:t>互联的影响</a:t>
+              <a:t>或</a:t>
+            </a:r>
+            <a:r>
+              <a:rPr lang="en-US" altLang="zh-CN" dirty="0" smtClean="0"/>
+              <a:t>2</a:t>
+            </a:r>
+            <a:endParaRPr lang="zh-CN" altLang="en-US" dirty="0"/>
+          </a:p>
+        </p:txBody>
+      </p:sp>
+      <p:sp>
+        <p:nvSpPr>
+          <p:cNvPr id="32" name="文本框 31"/>
+          <p:cNvSpPr txBox="1"/>
+          <p:nvPr/>
+        </p:nvSpPr>
+        <p:spPr>
+          <a:xfrm>
+            <a:off x="745915" y="3807935"/>
+            <a:ext cx="4501553" cy="4247317"/>
+          </a:xfrm>
+          <a:prstGeom prst="rect">
+            <a:avLst/>
+          </a:prstGeom>
+          <a:noFill/>
+        </p:spPr>
+        <p:txBody>
+          <a:bodyPr wrap="none" rtlCol="0">
+            <a:spAutoFit/>
+          </a:bodyPr>
+          <a:lstStyle/>
+          <a:p>
+            <a:r>
+              <a:rPr lang="en-US" altLang="zh-CN" dirty="0" smtClean="0"/>
+              <a:t>GPU with CPU mem </a:t>
+            </a:r>
+            <a:endParaRPr lang="en-US" altLang="zh-CN" dirty="0"/>
+          </a:p>
+          <a:p>
+            <a:pPr marL="342900" indent="-342900">
+              <a:buAutoNum type="arabicPlain"/>
+            </a:pPr>
+            <a:r>
+              <a:rPr lang="en-US" altLang="zh-CN" dirty="0" smtClean="0"/>
+              <a:t> PCI-e 3.0</a:t>
+            </a:r>
+          </a:p>
+          <a:p>
+            <a:pPr marL="342900" indent="-342900">
+              <a:buAutoNum type="arabicPlain"/>
+            </a:pPr>
+            <a:r>
+              <a:rPr lang="en-US" altLang="zh-CN" dirty="0" smtClean="0"/>
+              <a:t> </a:t>
+            </a:r>
+            <a:r>
+              <a:rPr lang="en-US" altLang="zh-CN" dirty="0" err="1" smtClean="0"/>
+              <a:t>NVLink</a:t>
+            </a:r>
+            <a:r>
+              <a:rPr lang="en-US" altLang="zh-CN" dirty="0" smtClean="0"/>
+              <a:t> 2.0</a:t>
+            </a:r>
+          </a:p>
+          <a:p>
+            <a:r>
+              <a:rPr lang="en-US" altLang="zh-CN" dirty="0"/>
+              <a:t>CPU interconnects </a:t>
+            </a:r>
+          </a:p>
+          <a:p>
+            <a:r>
+              <a:rPr lang="en-US" altLang="zh-CN" dirty="0" smtClean="0"/>
+              <a:t>3    Intel </a:t>
+            </a:r>
+            <a:r>
+              <a:rPr lang="en-US" altLang="zh-CN" dirty="0"/>
+              <a:t>Xeon Ultra Path Interconnect (UPI</a:t>
+            </a:r>
+            <a:r>
+              <a:rPr lang="en-US" altLang="zh-CN" dirty="0" smtClean="0"/>
+              <a:t>)</a:t>
+            </a:r>
+          </a:p>
+          <a:p>
+            <a:r>
+              <a:rPr lang="en-US" altLang="zh-CN" dirty="0" smtClean="0"/>
+              <a:t>4    IBM </a:t>
+            </a:r>
+            <a:r>
+              <a:rPr lang="en-US" altLang="zh-CN" dirty="0"/>
+              <a:t>POWER9 </a:t>
+            </a:r>
+            <a:r>
+              <a:rPr lang="en-US" altLang="zh-CN" dirty="0" smtClean="0"/>
+              <a:t>X-Bus</a:t>
+            </a:r>
+          </a:p>
+          <a:p>
+            <a:r>
+              <a:rPr lang="en-US" altLang="zh-CN" dirty="0"/>
+              <a:t>CPU memory </a:t>
+            </a:r>
+            <a:endParaRPr lang="en-US" altLang="zh-CN" dirty="0" smtClean="0"/>
+          </a:p>
+          <a:p>
+            <a:r>
+              <a:rPr lang="en-US" altLang="zh-CN" dirty="0" smtClean="0"/>
+              <a:t>5    </a:t>
+            </a:r>
+            <a:r>
+              <a:rPr lang="en-US" altLang="zh-CN" dirty="0" smtClean="0">
+                <a:solidFill>
+                  <a:schemeClr val="dk1"/>
+                </a:solidFill>
+              </a:rPr>
+              <a:t>Intel Xeon</a:t>
+            </a:r>
+            <a:endParaRPr lang="en-US" altLang="zh-CN" dirty="0" smtClean="0"/>
+          </a:p>
+          <a:p>
+            <a:r>
+              <a:rPr lang="en-US" altLang="zh-CN" dirty="0" smtClean="0"/>
+              <a:t>6    </a:t>
+            </a:r>
+            <a:r>
+              <a:rPr lang="en-US" altLang="zh-CN" dirty="0" smtClean="0">
+                <a:solidFill>
+                  <a:schemeClr val="dk1"/>
+                </a:solidFill>
+              </a:rPr>
+              <a:t>IBM </a:t>
+            </a:r>
+            <a:r>
+              <a:rPr lang="en-US" altLang="zh-CN" dirty="0">
+                <a:solidFill>
+                  <a:schemeClr val="dk1"/>
+                </a:solidFill>
+              </a:rPr>
+              <a:t>POWER9</a:t>
+            </a:r>
+            <a:endParaRPr lang="en-US" altLang="zh-CN" dirty="0"/>
+          </a:p>
+          <a:p>
+            <a:r>
+              <a:rPr lang="en-US" altLang="zh-CN" dirty="0" smtClean="0"/>
+              <a:t>7    </a:t>
+            </a:r>
+            <a:r>
+              <a:rPr lang="en-US" altLang="zh-CN" dirty="0" err="1" smtClean="0">
+                <a:solidFill>
+                  <a:schemeClr val="dk1"/>
+                </a:solidFill>
+              </a:rPr>
+              <a:t>Nvidia</a:t>
+            </a:r>
+            <a:r>
+              <a:rPr lang="en-US" altLang="zh-CN" dirty="0" smtClean="0">
+                <a:solidFill>
+                  <a:schemeClr val="dk1"/>
+                </a:solidFill>
+              </a:rPr>
+              <a:t> </a:t>
+            </a:r>
+            <a:r>
+              <a:rPr lang="en-US" altLang="zh-CN" dirty="0">
+                <a:solidFill>
+                  <a:schemeClr val="dk1"/>
+                </a:solidFill>
+              </a:rPr>
+              <a:t>V100</a:t>
+            </a:r>
+            <a:endParaRPr lang="en-US" altLang="zh-CN" dirty="0"/>
+          </a:p>
+          <a:p>
+            <a:endParaRPr lang="en-US" altLang="zh-CN" dirty="0" smtClean="0"/>
+          </a:p>
+          <a:p>
+            <a:endParaRPr lang="en-US" altLang="zh-CN" dirty="0"/>
+          </a:p>
+          <a:p>
+            <a:endParaRPr lang="en-US" altLang="zh-CN" dirty="0" smtClean="0"/>
+          </a:p>
+          <a:p>
+            <a:endParaRPr lang="en-US" altLang="zh-CN" dirty="0" smtClean="0"/>
+          </a:p>
+          <a:p>
+            <a:pPr marL="342900" indent="-342900">
+              <a:buAutoNum type="arabicPlain"/>
+            </a:pPr>
+            <a:endParaRPr lang="zh-CN" altLang="en-US" dirty="0"/>
+          </a:p>
+        </p:txBody>
+      </p:sp>
+      <p:cxnSp>
+        <p:nvCxnSpPr>
+          <p:cNvPr id="40" name="曲线连接符 39"/>
+          <p:cNvCxnSpPr/>
+          <p:nvPr/>
+        </p:nvCxnSpPr>
+        <p:spPr>
+          <a:xfrm flipV="1">
+            <a:off x="2388017" y="1346075"/>
+            <a:ext cx="498157" cy="1840136"/>
+          </a:xfrm>
+          <a:prstGeom prst="curvedConnector2">
+            <a:avLst/>
+          </a:prstGeom>
+          <a:ln>
+            <a:tailEnd type="triangle"/>
+          </a:ln>
+        </p:spPr>
+        <p:style>
+          <a:lnRef idx="1">
+            <a:schemeClr val="dk1"/>
+          </a:lnRef>
+          <a:fillRef idx="0">
+            <a:schemeClr val="dk1"/>
+          </a:fillRef>
+          <a:effectRef idx="0">
+            <a:schemeClr val="dk1"/>
+          </a:effectRef>
+          <a:fontRef idx="minor">
+            <a:schemeClr val="tx1"/>
+          </a:fontRef>
+        </p:style>
+      </p:cxnSp>
+      <p:sp>
+        <p:nvSpPr>
+          <p:cNvPr id="46" name="文本框 45"/>
+          <p:cNvSpPr txBox="1"/>
+          <p:nvPr/>
+        </p:nvSpPr>
+        <p:spPr>
+          <a:xfrm>
+            <a:off x="2218822" y="1998071"/>
+            <a:ext cx="659155" cy="369332"/>
+          </a:xfrm>
+          <a:prstGeom prst="rect">
+            <a:avLst/>
+          </a:prstGeom>
+          <a:noFill/>
+        </p:spPr>
+        <p:txBody>
+          <a:bodyPr wrap="none" rtlCol="0">
+            <a:spAutoFit/>
+          </a:bodyPr>
+          <a:lstStyle/>
+          <a:p>
+            <a:r>
+              <a:rPr lang="en-US" altLang="zh-CN" dirty="0"/>
+              <a:t>3</a:t>
+            </a:r>
+            <a:r>
+              <a:rPr lang="zh-CN" altLang="en-US" dirty="0" smtClean="0"/>
+              <a:t>或</a:t>
+            </a:r>
+            <a:r>
+              <a:rPr lang="en-US" altLang="zh-CN" dirty="0"/>
+              <a:t>4</a:t>
+            </a:r>
+            <a:endParaRPr lang="zh-CN" altLang="en-US" dirty="0"/>
+          </a:p>
+        </p:txBody>
+      </p:sp>
+      <p:graphicFrame>
+        <p:nvGraphicFramePr>
+          <p:cNvPr id="47" name="表格 46"/>
+          <p:cNvGraphicFramePr>
+            <a:graphicFrameLocks noGrp="1"/>
+          </p:cNvGraphicFramePr>
+          <p:nvPr>
+            <p:extLst>
+              <p:ext uri="{D42A27DB-BD31-4B8C-83A1-F6EECF244321}">
+                <p14:modId xmlns:p14="http://schemas.microsoft.com/office/powerpoint/2010/main" val="4112918327"/>
+              </p:ext>
+            </p:extLst>
+          </p:nvPr>
+        </p:nvGraphicFramePr>
+        <p:xfrm>
+          <a:off x="6962090" y="765372"/>
+          <a:ext cx="4083062" cy="5824945"/>
+        </p:xfrm>
+        <a:graphic>
+          <a:graphicData uri="http://schemas.openxmlformats.org/drawingml/2006/table">
+            <a:tbl>
+              <a:tblPr firstRow="1" bandRow="1">
+                <a:tableStyleId>{5C22544A-7EE6-4342-B048-85BDC9FD1C3A}</a:tableStyleId>
+              </a:tblPr>
+              <a:tblGrid>
+                <a:gridCol w="2041531">
+                  <a:extLst>
+                    <a:ext uri="{9D8B030D-6E8A-4147-A177-3AD203B41FA5}">
+                      <a16:colId xmlns:a16="http://schemas.microsoft.com/office/drawing/2014/main" val="2104862403"/>
+                    </a:ext>
+                  </a:extLst>
+                </a:gridCol>
+                <a:gridCol w="2041531">
+                  <a:extLst>
+                    <a:ext uri="{9D8B030D-6E8A-4147-A177-3AD203B41FA5}">
+                      <a16:colId xmlns:a16="http://schemas.microsoft.com/office/drawing/2014/main" val="3631488225"/>
+                    </a:ext>
+                  </a:extLst>
+                </a:gridCol>
+              </a:tblGrid>
+              <a:tr h="406243">
+                <a:tc>
+                  <a:txBody>
+                    <a:bodyPr/>
+                    <a:lstStyle/>
+                    <a:p>
+                      <a:r>
+                        <a:rPr lang="zh-CN" altLang="en-US" dirty="0" smtClean="0"/>
+                        <a:t>总线</a:t>
+                      </a:r>
+                      <a:endParaRPr lang="zh-CN" altLang="en-US" dirty="0"/>
+                    </a:p>
+                  </a:txBody>
+                  <a:tcPr/>
+                </a:tc>
+                <a:tc>
+                  <a:txBody>
+                    <a:bodyPr/>
+                    <a:lstStyle/>
+                    <a:p>
+                      <a:r>
+                        <a:rPr lang="zh-CN" altLang="en-US" dirty="0" smtClean="0"/>
+                        <a:t>带宽</a:t>
+                      </a:r>
+                      <a:r>
+                        <a:rPr lang="en-US" altLang="zh-CN" dirty="0" err="1" smtClean="0"/>
+                        <a:t>GiB</a:t>
+                      </a:r>
+                      <a:r>
+                        <a:rPr lang="en-US" altLang="zh-CN" dirty="0" smtClean="0"/>
+                        <a:t>/s</a:t>
+                      </a:r>
+                      <a:endParaRPr lang="zh-CN" altLang="en-US" dirty="0"/>
+                    </a:p>
+                  </a:txBody>
+                  <a:tcPr/>
+                </a:tc>
+                <a:extLst>
+                  <a:ext uri="{0D108BD9-81ED-4DB2-BD59-A6C34878D82A}">
+                    <a16:rowId xmlns:a16="http://schemas.microsoft.com/office/drawing/2014/main" val="3322635084"/>
+                  </a:ext>
+                </a:extLst>
+              </a:tr>
+              <a:tr h="1031046">
+                <a:tc>
+                  <a:txBody>
+                    <a:bodyPr/>
+                    <a:lstStyle/>
+                    <a:p>
+                      <a:pPr marL="0" indent="0">
+                        <a:buNone/>
+                      </a:pPr>
+                      <a:r>
+                        <a:rPr lang="en-US" altLang="zh-CN" dirty="0" smtClean="0"/>
+                        <a:t>1  PCI-e 3.0</a:t>
+                      </a:r>
+                    </a:p>
+                  </a:txBody>
+                  <a:tcPr/>
+                </a:tc>
+                <a:tc>
+                  <a:txBody>
+                    <a:bodyPr/>
+                    <a:lstStyle/>
+                    <a:p>
+                      <a:r>
+                        <a:rPr lang="en-US" altLang="zh-CN" dirty="0" smtClean="0"/>
+                        <a:t>12</a:t>
+                      </a:r>
+                      <a:endParaRPr lang="zh-CN" altLang="en-US" dirty="0"/>
+                    </a:p>
+                  </a:txBody>
+                  <a:tcPr/>
+                </a:tc>
+                <a:extLst>
+                  <a:ext uri="{0D108BD9-81ED-4DB2-BD59-A6C34878D82A}">
+                    <a16:rowId xmlns:a16="http://schemas.microsoft.com/office/drawing/2014/main" val="4110064030"/>
+                  </a:ext>
+                </a:extLst>
+              </a:tr>
+              <a:tr h="731276">
+                <a:tc>
+                  <a:txBody>
+                    <a:bodyPr/>
+                    <a:lstStyle/>
+                    <a:p>
+                      <a:pPr marL="0" indent="0">
+                        <a:buNone/>
+                      </a:pPr>
+                      <a:r>
+                        <a:rPr lang="en-US" altLang="zh-CN" dirty="0" smtClean="0"/>
+                        <a:t>2   </a:t>
+                      </a:r>
+                      <a:r>
+                        <a:rPr lang="en-US" altLang="zh-CN" dirty="0" err="1" smtClean="0"/>
+                        <a:t>NVLink</a:t>
+                      </a:r>
+                      <a:r>
+                        <a:rPr lang="en-US" altLang="zh-CN" dirty="0" smtClean="0"/>
+                        <a:t> 2.0</a:t>
+                      </a:r>
+                    </a:p>
+                  </a:txBody>
+                  <a:tcPr/>
+                </a:tc>
+                <a:tc>
+                  <a:txBody>
+                    <a:bodyPr/>
+                    <a:lstStyle/>
+                    <a:p>
+                      <a:r>
+                        <a:rPr lang="en-US" altLang="zh-CN" dirty="0" smtClean="0"/>
+                        <a:t>63</a:t>
+                      </a:r>
+                      <a:endParaRPr lang="zh-CN" altLang="en-US" dirty="0"/>
+                    </a:p>
+                  </a:txBody>
+                  <a:tcPr/>
+                </a:tc>
+                <a:extLst>
+                  <a:ext uri="{0D108BD9-81ED-4DB2-BD59-A6C34878D82A}">
+                    <a16:rowId xmlns:a16="http://schemas.microsoft.com/office/drawing/2014/main" val="487215583"/>
+                  </a:ext>
+                </a:extLst>
+              </a:tr>
+              <a:tr h="731276">
+                <a:tc>
+                  <a:txBody>
+                    <a:bodyPr/>
+                    <a:lstStyle/>
+                    <a:p>
+                      <a:pPr marL="0" indent="0">
+                        <a:buNone/>
+                      </a:pPr>
+                      <a:r>
+                        <a:rPr lang="en-US" altLang="zh-CN" dirty="0" smtClean="0"/>
+                        <a:t>3  UPI</a:t>
+                      </a:r>
+                    </a:p>
+                  </a:txBody>
+                  <a:tcPr/>
+                </a:tc>
+                <a:tc>
+                  <a:txBody>
+                    <a:bodyPr/>
+                    <a:lstStyle/>
+                    <a:p>
+                      <a:r>
+                        <a:rPr lang="en-US" altLang="zh-CN" dirty="0" smtClean="0"/>
+                        <a:t>32</a:t>
+                      </a:r>
+                      <a:endParaRPr lang="zh-CN" altLang="en-US" dirty="0"/>
+                    </a:p>
+                  </a:txBody>
+                  <a:tcPr/>
+                </a:tc>
+                <a:extLst>
+                  <a:ext uri="{0D108BD9-81ED-4DB2-BD59-A6C34878D82A}">
+                    <a16:rowId xmlns:a16="http://schemas.microsoft.com/office/drawing/2014/main" val="976593517"/>
+                  </a:ext>
+                </a:extLst>
+              </a:tr>
+              <a:tr h="731276">
+                <a:tc>
+                  <a:txBody>
+                    <a:bodyPr/>
+                    <a:lstStyle/>
+                    <a:p>
+                      <a:pPr marL="0" marR="0" indent="0" algn="l" defTabSz="914400" rtl="0" eaLnBrk="1" fontAlgn="auto" latinLnBrk="0" hangingPunct="1">
+                        <a:lnSpc>
+                          <a:spcPct val="100000"/>
+                        </a:lnSpc>
+                        <a:spcBef>
+                          <a:spcPts val="0"/>
+                        </a:spcBef>
+                        <a:spcAft>
+                          <a:spcPts val="0"/>
+                        </a:spcAft>
+                        <a:buClrTx/>
+                        <a:buSzTx/>
+                        <a:buFontTx/>
+                        <a:buNone/>
+                        <a:tabLst/>
+                        <a:defRPr/>
+                      </a:pPr>
+                      <a:r>
+                        <a:rPr lang="en-US" altLang="zh-CN" dirty="0" smtClean="0"/>
+                        <a:t>4 X-Bus</a:t>
+                      </a:r>
+                    </a:p>
+                    <a:p>
+                      <a:pPr marL="0" indent="0">
+                        <a:buNone/>
+                      </a:pPr>
+                      <a:endParaRPr lang="en-US" altLang="zh-CN" dirty="0" smtClean="0"/>
+                    </a:p>
+                  </a:txBody>
+                  <a:tcPr/>
+                </a:tc>
+                <a:tc>
+                  <a:txBody>
+                    <a:bodyPr/>
+                    <a:lstStyle/>
+                    <a:p>
+                      <a:r>
+                        <a:rPr lang="en-US" altLang="zh-CN" dirty="0" smtClean="0"/>
+                        <a:t>31</a:t>
+                      </a:r>
+                      <a:endParaRPr lang="zh-CN" altLang="en-US" dirty="0"/>
+                    </a:p>
+                  </a:txBody>
+                  <a:tcPr/>
+                </a:tc>
+                <a:extLst>
+                  <a:ext uri="{0D108BD9-81ED-4DB2-BD59-A6C34878D82A}">
+                    <a16:rowId xmlns:a16="http://schemas.microsoft.com/office/drawing/2014/main" val="1875395145"/>
+                  </a:ext>
+                </a:extLst>
+              </a:tr>
+              <a:tr h="731276">
+                <a:tc>
+                  <a:txBody>
+                    <a:bodyPr/>
+                    <a:lstStyle/>
+                    <a:p>
+                      <a:pPr marL="0" indent="0">
+                        <a:buNone/>
+                      </a:pPr>
+                      <a:r>
+                        <a:rPr lang="en-US" altLang="zh-CN" dirty="0" smtClean="0"/>
+                        <a:t>5</a:t>
+                      </a:r>
+                      <a:r>
+                        <a:rPr lang="en-US" altLang="zh-CN" sz="1800" b="0" i="0" kern="1200" dirty="0" smtClean="0">
+                          <a:solidFill>
+                            <a:schemeClr val="dk1"/>
+                          </a:solidFill>
+                          <a:effectLst/>
+                          <a:latin typeface="+mn-lt"/>
+                          <a:ea typeface="+mn-ea"/>
+                          <a:cs typeface="+mn-cs"/>
+                        </a:rPr>
+                        <a:t>Intel Xeon</a:t>
+                      </a:r>
+                      <a:endParaRPr lang="en-US" altLang="zh-CN" dirty="0" smtClean="0"/>
+                    </a:p>
+                  </a:txBody>
+                  <a:tcPr/>
+                </a:tc>
+                <a:tc>
+                  <a:txBody>
+                    <a:bodyPr/>
+                    <a:lstStyle/>
+                    <a:p>
+                      <a:r>
+                        <a:rPr lang="en-US" altLang="zh-CN" dirty="0" smtClean="0"/>
+                        <a:t>81</a:t>
+                      </a:r>
+                      <a:endParaRPr lang="zh-CN" altLang="en-US" dirty="0"/>
+                    </a:p>
+                  </a:txBody>
+                  <a:tcPr/>
+                </a:tc>
+                <a:extLst>
+                  <a:ext uri="{0D108BD9-81ED-4DB2-BD59-A6C34878D82A}">
+                    <a16:rowId xmlns:a16="http://schemas.microsoft.com/office/drawing/2014/main" val="2168560015"/>
+                  </a:ext>
+                </a:extLst>
+              </a:tr>
+              <a:tr h="731276">
+                <a:tc>
+                  <a:txBody>
+                    <a:bodyPr/>
+                    <a:lstStyle/>
+                    <a:p>
+                      <a:pPr marL="0" indent="0">
+                        <a:buNone/>
+                      </a:pPr>
+                      <a:r>
+                        <a:rPr lang="en-US" altLang="zh-CN" dirty="0" smtClean="0"/>
+                        <a:t>6</a:t>
+                      </a:r>
+                      <a:r>
+                        <a:rPr lang="en-US" altLang="zh-CN" sz="1800" b="0" i="0" kern="1200" dirty="0" smtClean="0">
+                          <a:solidFill>
+                            <a:schemeClr val="dk1"/>
+                          </a:solidFill>
+                          <a:effectLst/>
+                          <a:latin typeface="+mn-lt"/>
+                          <a:ea typeface="+mn-ea"/>
+                          <a:cs typeface="+mn-cs"/>
+                        </a:rPr>
+                        <a:t>IBM POWER9</a:t>
+                      </a:r>
+                      <a:endParaRPr lang="en-US" altLang="zh-CN" dirty="0" smtClean="0"/>
+                    </a:p>
+                  </a:txBody>
+                  <a:tcPr/>
+                </a:tc>
+                <a:tc>
+                  <a:txBody>
+                    <a:bodyPr/>
+                    <a:lstStyle/>
+                    <a:p>
+                      <a:r>
+                        <a:rPr lang="en-US" altLang="zh-CN" dirty="0" smtClean="0"/>
+                        <a:t>117</a:t>
+                      </a:r>
+                      <a:endParaRPr lang="zh-CN" altLang="en-US" dirty="0"/>
+                    </a:p>
+                  </a:txBody>
+                  <a:tcPr/>
+                </a:tc>
+                <a:extLst>
+                  <a:ext uri="{0D108BD9-81ED-4DB2-BD59-A6C34878D82A}">
+                    <a16:rowId xmlns:a16="http://schemas.microsoft.com/office/drawing/2014/main" val="2571877642"/>
+                  </a:ext>
+                </a:extLst>
+              </a:tr>
+              <a:tr h="731276">
+                <a:tc>
+                  <a:txBody>
+                    <a:bodyPr/>
+                    <a:lstStyle/>
+                    <a:p>
+                      <a:pPr marL="0" indent="0">
+                        <a:buNone/>
+                      </a:pPr>
+                      <a:r>
+                        <a:rPr lang="en-US" altLang="zh-CN" dirty="0" smtClean="0"/>
+                        <a:t>7</a:t>
+                      </a:r>
+                      <a:r>
+                        <a:rPr lang="en-US" altLang="zh-CN" sz="1800" b="0" i="0" kern="1200" dirty="0" smtClean="0">
+                          <a:solidFill>
+                            <a:schemeClr val="dk1"/>
+                          </a:solidFill>
+                          <a:effectLst/>
+                          <a:latin typeface="+mn-lt"/>
+                          <a:ea typeface="+mn-ea"/>
+                          <a:cs typeface="+mn-cs"/>
+                        </a:rPr>
+                        <a:t>Nvidia V100</a:t>
+                      </a:r>
+                      <a:endParaRPr lang="en-US" altLang="zh-CN" dirty="0" smtClean="0"/>
+                    </a:p>
+                  </a:txBody>
+                  <a:tcPr/>
+                </a:tc>
+                <a:tc>
+                  <a:txBody>
+                    <a:bodyPr/>
+                    <a:lstStyle/>
+                    <a:p>
+                      <a:r>
+                        <a:rPr lang="en-US" altLang="zh-CN" dirty="0" smtClean="0"/>
+                        <a:t>729</a:t>
+                      </a:r>
+                      <a:endParaRPr lang="zh-CN" altLang="en-US" dirty="0"/>
+                    </a:p>
+                  </a:txBody>
+                  <a:tcPr/>
+                </a:tc>
+                <a:extLst>
+                  <a:ext uri="{0D108BD9-81ED-4DB2-BD59-A6C34878D82A}">
+                    <a16:rowId xmlns:a16="http://schemas.microsoft.com/office/drawing/2014/main" val="2872256530"/>
+                  </a:ext>
+                </a:extLst>
+              </a:tr>
+            </a:tbl>
+          </a:graphicData>
+        </a:graphic>
+      </p:graphicFrame>
+      <p:sp>
+        <p:nvSpPr>
+          <p:cNvPr id="49" name="文本框 48"/>
+          <p:cNvSpPr txBox="1"/>
+          <p:nvPr/>
+        </p:nvSpPr>
+        <p:spPr>
+          <a:xfrm>
+            <a:off x="2057482" y="701177"/>
+            <a:ext cx="659155" cy="369332"/>
+          </a:xfrm>
+          <a:prstGeom prst="rect">
+            <a:avLst/>
+          </a:prstGeom>
+          <a:noFill/>
+        </p:spPr>
+        <p:txBody>
+          <a:bodyPr wrap="none" rtlCol="0">
+            <a:spAutoFit/>
+          </a:bodyPr>
+          <a:lstStyle/>
+          <a:p>
+            <a:r>
+              <a:rPr lang="en-US" altLang="zh-CN" dirty="0"/>
+              <a:t>5</a:t>
+            </a:r>
+            <a:r>
+              <a:rPr lang="zh-CN" altLang="en-US" dirty="0" smtClean="0"/>
+              <a:t>或</a:t>
+            </a:r>
+            <a:r>
+              <a:rPr lang="en-US" altLang="zh-CN" dirty="0"/>
+              <a:t>6</a:t>
+            </a:r>
+            <a:endParaRPr lang="zh-CN" altLang="en-US" dirty="0"/>
+          </a:p>
+        </p:txBody>
+      </p:sp>
+      <p:cxnSp>
+        <p:nvCxnSpPr>
+          <p:cNvPr id="50" name="直接箭头连接符 49"/>
+          <p:cNvCxnSpPr>
+            <a:endCxn id="4" idx="1"/>
+          </p:cNvCxnSpPr>
+          <p:nvPr/>
+        </p:nvCxnSpPr>
+        <p:spPr>
+          <a:xfrm>
+            <a:off x="1815766" y="1106937"/>
+            <a:ext cx="806113" cy="3441"/>
+          </a:xfrm>
+          <a:prstGeom prst="straightConnector1">
+            <a:avLst/>
+          </a:prstGeom>
+          <a:ln>
+            <a:prstDash val="dashDot"/>
+            <a:tailEnd type="triangle"/>
+          </a:ln>
+        </p:spPr>
+        <p:style>
+          <a:lnRef idx="1">
+            <a:schemeClr val="dk1"/>
+          </a:lnRef>
+          <a:fillRef idx="0">
+            <a:schemeClr val="dk1"/>
+          </a:fillRef>
+          <a:effectRef idx="0">
+            <a:schemeClr val="dk1"/>
+          </a:effectRef>
+          <a:fontRef idx="minor">
+            <a:schemeClr val="tx1"/>
+          </a:fontRef>
+        </p:style>
+      </p:cxnSp>
+      <p:cxnSp>
+        <p:nvCxnSpPr>
+          <p:cNvPr id="56" name="直接箭头连接符 55"/>
+          <p:cNvCxnSpPr>
+            <a:endCxn id="11" idx="3"/>
+          </p:cNvCxnSpPr>
+          <p:nvPr/>
+        </p:nvCxnSpPr>
+        <p:spPr>
+          <a:xfrm flipH="1">
+            <a:off x="4686914" y="1070509"/>
+            <a:ext cx="754703" cy="1745"/>
+          </a:xfrm>
+          <a:prstGeom prst="straightConnector1">
+            <a:avLst/>
+          </a:prstGeom>
+          <a:ln>
+            <a:prstDash val="dashDot"/>
+            <a:tailEnd type="triangle"/>
+          </a:ln>
+        </p:spPr>
+        <p:style>
+          <a:lnRef idx="1">
+            <a:schemeClr val="dk1"/>
+          </a:lnRef>
+          <a:fillRef idx="0">
+            <a:schemeClr val="dk1"/>
+          </a:fillRef>
+          <a:effectRef idx="0">
+            <a:schemeClr val="dk1"/>
+          </a:effectRef>
+          <a:fontRef idx="minor">
+            <a:schemeClr val="tx1"/>
+          </a:fontRef>
+        </p:style>
+      </p:cxnSp>
+      <p:sp>
+        <p:nvSpPr>
+          <p:cNvPr id="59" name="文本框 58"/>
+          <p:cNvSpPr txBox="1"/>
+          <p:nvPr/>
+        </p:nvSpPr>
+        <p:spPr>
+          <a:xfrm>
+            <a:off x="4678669" y="741802"/>
+            <a:ext cx="306494" cy="369332"/>
+          </a:xfrm>
+          <a:prstGeom prst="rect">
+            <a:avLst/>
+          </a:prstGeom>
+          <a:noFill/>
+        </p:spPr>
+        <p:txBody>
+          <a:bodyPr wrap="none" rtlCol="0">
+            <a:spAutoFit/>
+          </a:bodyPr>
+          <a:lstStyle/>
+          <a:p>
+            <a:r>
+              <a:rPr lang="en-US" altLang="zh-CN" dirty="0" smtClean="0"/>
+              <a:t>7</a:t>
             </a:r>
             <a:endParaRPr lang="zh-CN" altLang="en-US" dirty="0"/>
           </a:p>
@@ -21883,7 +21822,7 @@
     </p:spTree>
     <p:extLst>
       <p:ext uri="{BB962C8B-B14F-4D97-AF65-F5344CB8AC3E}">
-        <p14:creationId xmlns:p14="http://schemas.microsoft.com/office/powerpoint/2010/main" val="2371099565"/>
+        <p14:creationId xmlns:p14="http://schemas.microsoft.com/office/powerpoint/2010/main" val="2345161636"/>
       </p:ext>
     </p:extLst>
   </p:cSld>

</xml_diff>

<commit_message>
revise weekly report and send it
</commit_message>
<xml_diff>
--- a/week report/8.18 report.pptx
+++ b/week report/8.18 report.pptx
@@ -17116,7 +17116,7 @@
           <p:nvPr>
             <p:extLst>
               <p:ext uri="{D42A27DB-BD31-4B8C-83A1-F6EECF244321}">
-                <p14:modId xmlns:p14="http://schemas.microsoft.com/office/powerpoint/2010/main" val="2522570103"/>
+                <p14:modId xmlns:p14="http://schemas.microsoft.com/office/powerpoint/2010/main" val="1579134068"/>
               </p:ext>
             </p:extLst>
           </p:nvPr>
@@ -17232,12 +17232,8 @@
                     <a:lstStyle/>
                     <a:p>
                       <a:r>
-                        <a:rPr lang="zh-CN" altLang="en-US" dirty="0" smtClean="0"/>
-                        <a:t>有游戏的层次</a:t>
-                      </a:r>
-                      <a:r>
                         <a:rPr lang="en-US" altLang="zh-CN" dirty="0" smtClean="0"/>
-                        <a:t>RL. </a:t>
+                        <a:t>Pollux</a:t>
                       </a:r>
                       <a:endParaRPr lang="zh-CN" altLang="en-US" dirty="0"/>
                     </a:p>
@@ -17251,11 +17247,19 @@
                     <a:p>
                       <a:r>
                         <a:rPr lang="zh-CN" altLang="en-US" dirty="0" smtClean="0"/>
-                        <a:t>需要尝试 层次</a:t>
+                        <a:t>需要研究怎么结合</a:t>
                       </a:r>
                       <a:r>
-                        <a:rPr lang="en-US" altLang="zh-CN" dirty="0" smtClean="0"/>
-                        <a:t>RL</a:t>
+                        <a:rPr lang="en-US" altLang="zh-CN" dirty="0" err="1" smtClean="0"/>
+                        <a:t>pollux</a:t>
+                      </a:r>
+                      <a:r>
+                        <a:rPr lang="zh-CN" altLang="en-US" dirty="0" smtClean="0"/>
+                        <a:t>和</a:t>
+                      </a:r>
+                      <a:r>
+                        <a:rPr lang="en-US" altLang="zh-CN" smtClean="0"/>
+                        <a:t>DRL</a:t>
                       </a:r>
                       <a:endParaRPr lang="zh-CN" altLang="en-US" dirty="0"/>
                     </a:p>
@@ -17382,38 +17386,8 @@
                     <a:lstStyle/>
                     <a:p>
                       <a:r>
-                        <a:rPr lang="zh-CN" altLang="en-US" dirty="0" smtClean="0"/>
-                        <a:t>根据</a:t>
-                      </a:r>
-                      <a:r>
-                        <a:rPr lang="en-US" altLang="zh-CN" dirty="0" err="1" smtClean="0"/>
-                        <a:t>baoyixin</a:t>
-                      </a:r>
-                      <a:r>
-                        <a:rPr lang="zh-CN" altLang="en-US" dirty="0" smtClean="0"/>
-                        <a:t>所述的</a:t>
-                      </a:r>
-                      <a:r>
-                        <a:rPr lang="en-US" altLang="zh-CN" dirty="0" err="1" smtClean="0"/>
-                        <a:t>github</a:t>
-                      </a:r>
-                      <a:r>
-                        <a:rPr lang="zh-CN" altLang="en-US" dirty="0" smtClean="0"/>
-                        <a:t>代码</a:t>
-                      </a:r>
-                      <a:r>
                         <a:rPr lang="en-US" altLang="zh-CN" dirty="0" smtClean="0"/>
-                        <a:t>.</a:t>
-                      </a:r>
-                    </a:p>
-                    <a:p>
-                      <a:r>
-                        <a:rPr lang="zh-CN" altLang="en-US" dirty="0" smtClean="0"/>
-                        <a:t>复现</a:t>
-                      </a:r>
-                      <a:r>
-                        <a:rPr lang="en-US" altLang="zh-CN" dirty="0" smtClean="0"/>
-                        <a:t>DL2.</a:t>
+                        <a:t>DL2</a:t>
                       </a:r>
                       <a:endParaRPr lang="zh-CN" altLang="en-US" dirty="0"/>
                     </a:p>
@@ -17427,22 +17401,23 @@
                     <a:p>
                       <a:r>
                         <a:rPr lang="zh-CN" altLang="en-US" dirty="0" smtClean="0"/>
-                        <a:t>写出基本的</a:t>
+                        <a:t>完成</a:t>
+                      </a:r>
+                      <a:r>
+                        <a:rPr lang="zh-CN" altLang="en-US" dirty="0" smtClean="0"/>
+                        <a:t>了</a:t>
                       </a:r>
                       <a:r>
                         <a:rPr lang="en-US" altLang="zh-CN" dirty="0" smtClean="0"/>
-                        <a:t>DRL.</a:t>
+                        <a:t>trace</a:t>
                       </a:r>
-                    </a:p>
-                    <a:p>
-                      <a:pPr algn="ctr"/>
                       <a:r>
                         <a:rPr lang="zh-CN" altLang="en-US" dirty="0" smtClean="0"/>
-                        <a:t>正在复现</a:t>
+                        <a:t>提取</a:t>
                       </a:r>
                       <a:r>
                         <a:rPr lang="en-US" altLang="zh-CN" dirty="0" smtClean="0"/>
-                        <a:t>DL2 </a:t>
+                        <a:t>,cluster, </a:t>
                       </a:r>
                       <a:endParaRPr lang="zh-CN" altLang="en-US" dirty="0"/>
                     </a:p>
@@ -18086,19 +18061,13 @@
             </a:r>
             <a:r>
               <a:rPr lang="zh-CN" altLang="en-US" dirty="0" smtClean="0"/>
-              <a:t>的 通讯时间估计</a:t>
+              <a:t>的 通讯</a:t>
+            </a:r>
+            <a:r>
+              <a:rPr lang="zh-CN" altLang="en-US" dirty="0" smtClean="0"/>
+              <a:t>时间估计</a:t>
             </a:r>
             <a:endParaRPr lang="en-US" altLang="zh-CN" dirty="0" smtClean="0"/>
-          </a:p>
-          <a:p>
-            <a:pPr marL="0" indent="0">
-              <a:buNone/>
-            </a:pPr>
-            <a:endParaRPr lang="en-US" altLang="zh-CN" dirty="0" smtClean="0"/>
-          </a:p>
-          <a:p>
-            <a:pPr lvl="0"/>
-            <a:endParaRPr lang="zh-CN" altLang="en-US" dirty="0"/>
           </a:p>
         </p:txBody>
       </p:sp>
@@ -20204,11 +20173,7 @@
                     <a:p>
                       <a:r>
                         <a:rPr lang="zh-CN" altLang="en-US" dirty="0" smtClean="0"/>
-                        <a:t>学习</a:t>
-                      </a:r>
-                      <a:r>
-                        <a:rPr lang="zh-CN" altLang="en-US" dirty="0" smtClean="0"/>
-                        <a:t>率</a:t>
+                        <a:t>学习率</a:t>
                       </a:r>
                       <a:r>
                         <a:rPr lang="en-US" altLang="zh-CN" dirty="0" smtClean="0"/>

</xml_diff>